<commit_message>
docs: modif présentation ajout conclusion + snapshots emails
</commit_message>
<xml_diff>
--- a/docs/AIA_bloc3_fraud_detection_GV.pptx
+++ b/docs/AIA_bloc3_fraud_detection_GV.pptx
@@ -21,23 +21,26 @@
     <p:sldId id="266" r:id="rId17"/>
     <p:sldId id="267" r:id="rId18"/>
     <p:sldId id="268" r:id="rId19"/>
+    <p:sldId id="269" r:id="rId20"/>
+    <p:sldId id="270" r:id="rId21"/>
+    <p:sldId id="271" r:id="rId22"/>
   </p:sldIdLst>
   <p:sldSz cy="5143500" cx="9144000"/>
   <p:notesSz cx="6858000" cy="9144000"/>
   <p:embeddedFontLst>
     <p:embeddedFont>
       <p:font typeface="Roboto"/>
-      <p:regular r:id="rId20"/>
-      <p:bold r:id="rId21"/>
-      <p:italic r:id="rId22"/>
-      <p:boldItalic r:id="rId23"/>
+      <p:regular r:id="rId23"/>
+      <p:bold r:id="rId24"/>
+      <p:italic r:id="rId25"/>
+      <p:boldItalic r:id="rId26"/>
     </p:embeddedFont>
     <p:embeddedFont>
       <p:font typeface="Roboto Light"/>
-      <p:regular r:id="rId24"/>
-      <p:bold r:id="rId25"/>
-      <p:italic r:id="rId26"/>
-      <p:boldItalic r:id="rId27"/>
+      <p:regular r:id="rId27"/>
+      <p:bold r:id="rId28"/>
+      <p:italic r:id="rId29"/>
+      <p:boldItalic r:id="rId30"/>
     </p:embeddedFont>
   </p:embeddedFontLst>
   <p:defaultTextStyle>
@@ -1139,7 +1142,7 @@
       </p:grpSpPr>
       <p:sp>
         <p:nvSpPr>
-          <p:cNvPr id="159" name="Google Shape;159;g3f0fa6fd511_0_8:notes"/>
+          <p:cNvPr id="159" name="Google Shape;159;g3f0fa6fd511_0_115:notes"/>
           <p:cNvSpPr/>
           <p:nvPr>
             <p:ph idx="2" type="sldImg"/>
@@ -1174,7 +1177,520 @@
       </p:sp>
       <p:sp>
         <p:nvSpPr>
-          <p:cNvPr id="160" name="Google Shape;160;g3f0fa6fd511_0_8:notes"/>
+          <p:cNvPr id="160" name="Google Shape;160;g3f0fa6fd511_0_115:notes"/>
+          <p:cNvSpPr txBox="1"/>
+          <p:nvPr>
+            <p:ph idx="1" type="body"/>
+          </p:nvPr>
+        </p:nvSpPr>
+        <p:spPr>
+          <a:xfrm>
+            <a:off x="685800" y="4343400"/>
+            <a:ext cx="5486400" cy="4114800"/>
+          </a:xfrm>
+          <a:prstGeom prst="rect">
+            <a:avLst/>
+          </a:prstGeom>
+        </p:spPr>
+        <p:txBody>
+          <a:bodyPr anchorCtr="0" anchor="t" bIns="91425" lIns="91425" spcFirstLastPara="1" rIns="91425" wrap="square" tIns="91425">
+            <a:noAutofit/>
+          </a:bodyPr>
+          <a:lstStyle/>
+          <a:p>
+            <a:pPr indent="0" lvl="0" marL="0" rtl="0" algn="l">
+              <a:spcBef>
+                <a:spcPts val="0"/>
+              </a:spcBef>
+              <a:spcAft>
+                <a:spcPts val="0"/>
+              </a:spcAft>
+              <a:buNone/>
+            </a:pPr>
+            <a:r>
+              <a:t/>
+            </a:r>
+            <a:endParaRPr/>
+          </a:p>
+        </p:txBody>
+      </p:sp>
+    </p:spTree>
+  </p:cSld>
+  <p:clrMapOvr>
+    <a:masterClrMapping/>
+  </p:clrMapOvr>
+</p:notes>
+</file>
+
+<file path=ppt/notesSlides/notesSlide14.xml><?xml version="1.0" encoding="utf-8"?>
+<p:notes xmlns:a="http://schemas.openxmlformats.org/drawingml/2006/main" xmlns:r="http://schemas.openxmlformats.org/officeDocument/2006/relationships" xmlns:mc="http://schemas.openxmlformats.org/markup-compatibility/2006" xmlns:mv="urn:schemas-microsoft-com:mac:vml" xmlns:p="http://schemas.openxmlformats.org/presentationml/2006/main" xmlns:c="http://schemas.openxmlformats.org/drawingml/2006/chart" xmlns:dgm="http://schemas.openxmlformats.org/drawingml/2006/diagram" xmlns:o="urn:schemas-microsoft-com:office:office" xmlns:v="urn:schemas-microsoft-com:vml" xmlns:pvml="urn:schemas-microsoft-com:office:powerpoint" xmlns:com="http://schemas.openxmlformats.org/drawingml/2006/compatibility" xmlns:p14="http://schemas.microsoft.com/office/powerpoint/2010/main" xmlns:p15="http://schemas.microsoft.com/office/powerpoint/2012/main" xmlns:ahyp="http://schemas.microsoft.com/office/drawing/2018/hyperlinkcolor" showMasterPhAnim="0" showMasterSp="0">
+  <p:cSld>
+    <p:spTree>
+      <p:nvGrpSpPr>
+        <p:cNvPr id="168" name="Shape 168"/>
+        <p:cNvGrpSpPr/>
+        <p:nvPr/>
+      </p:nvGrpSpPr>
+      <p:grpSpPr>
+        <a:xfrm>
+          <a:off x="0" y="0"/>
+          <a:ext cx="0" cy="0"/>
+          <a:chOff x="0" y="0"/>
+          <a:chExt cx="0" cy="0"/>
+        </a:xfrm>
+      </p:grpSpPr>
+      <p:sp>
+        <p:nvSpPr>
+          <p:cNvPr id="169" name="Google Shape;169;g3f0fa6fd511_0_100:notes"/>
+          <p:cNvSpPr/>
+          <p:nvPr>
+            <p:ph idx="2" type="sldImg"/>
+          </p:nvPr>
+        </p:nvSpPr>
+        <p:spPr>
+          <a:xfrm>
+            <a:off x="381300" y="685800"/>
+            <a:ext cx="6096000" cy="3429000"/>
+          </a:xfrm>
+          <a:custGeom>
+            <a:rect b="b" l="l" r="r" t="t"/>
+            <a:pathLst>
+              <a:path extrusionOk="0" h="120000" w="120000">
+                <a:moveTo>
+                  <a:pt x="0" y="0"/>
+                </a:moveTo>
+                <a:lnTo>
+                  <a:pt x="120000" y="0"/>
+                </a:lnTo>
+                <a:lnTo>
+                  <a:pt x="120000" y="120000"/>
+                </a:lnTo>
+                <a:lnTo>
+                  <a:pt x="0" y="120000"/>
+                </a:lnTo>
+                <a:close/>
+              </a:path>
+            </a:pathLst>
+          </a:custGeom>
+        </p:spPr>
+      </p:sp>
+      <p:sp>
+        <p:nvSpPr>
+          <p:cNvPr id="170" name="Google Shape;170;g3f0fa6fd511_0_100:notes"/>
+          <p:cNvSpPr txBox="1"/>
+          <p:nvPr>
+            <p:ph idx="1" type="body"/>
+          </p:nvPr>
+        </p:nvSpPr>
+        <p:spPr>
+          <a:xfrm>
+            <a:off x="685800" y="4343400"/>
+            <a:ext cx="5486400" cy="4114800"/>
+          </a:xfrm>
+          <a:prstGeom prst="rect">
+            <a:avLst/>
+          </a:prstGeom>
+        </p:spPr>
+        <p:txBody>
+          <a:bodyPr anchorCtr="0" anchor="t" bIns="91425" lIns="91425" spcFirstLastPara="1" rIns="91425" wrap="square" tIns="91425">
+            <a:noAutofit/>
+          </a:bodyPr>
+          <a:lstStyle/>
+          <a:p>
+            <a:pPr indent="0" lvl="0" marL="0" rtl="0" algn="l">
+              <a:spcBef>
+                <a:spcPts val="0"/>
+              </a:spcBef>
+              <a:spcAft>
+                <a:spcPts val="0"/>
+              </a:spcAft>
+              <a:buNone/>
+            </a:pPr>
+            <a:r>
+              <a:t/>
+            </a:r>
+            <a:endParaRPr/>
+          </a:p>
+        </p:txBody>
+      </p:sp>
+    </p:spTree>
+  </p:cSld>
+  <p:clrMapOvr>
+    <a:masterClrMapping/>
+  </p:clrMapOvr>
+</p:notes>
+</file>
+
+<file path=ppt/notesSlides/notesSlide15.xml><?xml version="1.0" encoding="utf-8"?>
+<p:notes xmlns:a="http://schemas.openxmlformats.org/drawingml/2006/main" xmlns:r="http://schemas.openxmlformats.org/officeDocument/2006/relationships" xmlns:mc="http://schemas.openxmlformats.org/markup-compatibility/2006" xmlns:mv="urn:schemas-microsoft-com:mac:vml" xmlns:p="http://schemas.openxmlformats.org/presentationml/2006/main" xmlns:c="http://schemas.openxmlformats.org/drawingml/2006/chart" xmlns:dgm="http://schemas.openxmlformats.org/drawingml/2006/diagram" xmlns:o="urn:schemas-microsoft-com:office:office" xmlns:v="urn:schemas-microsoft-com:vml" xmlns:pvml="urn:schemas-microsoft-com:office:powerpoint" xmlns:com="http://schemas.openxmlformats.org/drawingml/2006/compatibility" xmlns:p14="http://schemas.microsoft.com/office/powerpoint/2010/main" xmlns:p15="http://schemas.microsoft.com/office/powerpoint/2012/main" xmlns:ahyp="http://schemas.microsoft.com/office/drawing/2018/hyperlinkcolor" showMasterPhAnim="0" showMasterSp="0">
+  <p:cSld>
+    <p:spTree>
+      <p:nvGrpSpPr>
+        <p:cNvPr id="176" name="Shape 176"/>
+        <p:cNvGrpSpPr/>
+        <p:nvPr/>
+      </p:nvGrpSpPr>
+      <p:grpSpPr>
+        <a:xfrm>
+          <a:off x="0" y="0"/>
+          <a:ext cx="0" cy="0"/>
+          <a:chOff x="0" y="0"/>
+          <a:chExt cx="0" cy="0"/>
+        </a:xfrm>
+      </p:grpSpPr>
+      <p:sp>
+        <p:nvSpPr>
+          <p:cNvPr id="177" name="Google Shape;177;g3f0fa6fd511_0_107:notes"/>
+          <p:cNvSpPr/>
+          <p:nvPr>
+            <p:ph idx="2" type="sldImg"/>
+          </p:nvPr>
+        </p:nvSpPr>
+        <p:spPr>
+          <a:xfrm>
+            <a:off x="381300" y="685800"/>
+            <a:ext cx="6096000" cy="3429000"/>
+          </a:xfrm>
+          <a:custGeom>
+            <a:rect b="b" l="l" r="r" t="t"/>
+            <a:pathLst>
+              <a:path extrusionOk="0" h="120000" w="120000">
+                <a:moveTo>
+                  <a:pt x="0" y="0"/>
+                </a:moveTo>
+                <a:lnTo>
+                  <a:pt x="120000" y="0"/>
+                </a:lnTo>
+                <a:lnTo>
+                  <a:pt x="120000" y="120000"/>
+                </a:lnTo>
+                <a:lnTo>
+                  <a:pt x="0" y="120000"/>
+                </a:lnTo>
+                <a:close/>
+              </a:path>
+            </a:pathLst>
+          </a:custGeom>
+        </p:spPr>
+      </p:sp>
+      <p:sp>
+        <p:nvSpPr>
+          <p:cNvPr id="178" name="Google Shape;178;g3f0fa6fd511_0_107:notes"/>
+          <p:cNvSpPr txBox="1"/>
+          <p:nvPr>
+            <p:ph idx="1" type="body"/>
+          </p:nvPr>
+        </p:nvSpPr>
+        <p:spPr>
+          <a:xfrm>
+            <a:off x="685800" y="4343400"/>
+            <a:ext cx="5486400" cy="4114800"/>
+          </a:xfrm>
+          <a:prstGeom prst="rect">
+            <a:avLst/>
+          </a:prstGeom>
+        </p:spPr>
+        <p:txBody>
+          <a:bodyPr anchorCtr="0" anchor="t" bIns="91425" lIns="91425" spcFirstLastPara="1" rIns="91425" wrap="square" tIns="91425">
+            <a:noAutofit/>
+          </a:bodyPr>
+          <a:lstStyle/>
+          <a:p>
+            <a:pPr indent="0" lvl="0" marL="0" rtl="0" algn="l">
+              <a:spcBef>
+                <a:spcPts val="0"/>
+              </a:spcBef>
+              <a:spcAft>
+                <a:spcPts val="0"/>
+              </a:spcAft>
+              <a:buNone/>
+            </a:pPr>
+            <a:r>
+              <a:rPr lang="fr">
+                <a:solidFill>
+                  <a:schemeClr val="dk1"/>
+                </a:solidFill>
+              </a:rPr>
+              <a:t>pourquoi PR-AUC ?</a:t>
+            </a:r>
+            <a:endParaRPr>
+              <a:solidFill>
+                <a:schemeClr val="dk1"/>
+              </a:solidFill>
+            </a:endParaRPr>
+          </a:p>
+          <a:p>
+            <a:pPr indent="-298450" lvl="0" marL="457200" rtl="0" algn="l">
+              <a:spcBef>
+                <a:spcPts val="0"/>
+              </a:spcBef>
+              <a:spcAft>
+                <a:spcPts val="0"/>
+              </a:spcAft>
+              <a:buClr>
+                <a:schemeClr val="dk1"/>
+              </a:buClr>
+              <a:buSzPts val="1100"/>
+              <a:buChar char="-"/>
+            </a:pPr>
+            <a:r>
+              <a:rPr lang="fr">
+                <a:solidFill>
+                  <a:schemeClr val="dk1"/>
+                </a:solidFill>
+              </a:rPr>
+              <a:t>La fraude est une classe très minoritaire (quelques % du dataset)</a:t>
+            </a:r>
+            <a:endParaRPr>
+              <a:solidFill>
+                <a:schemeClr val="dk1"/>
+              </a:solidFill>
+            </a:endParaRPr>
+          </a:p>
+          <a:p>
+            <a:pPr indent="-298450" lvl="0" marL="457200" rtl="0" algn="l">
+              <a:spcBef>
+                <a:spcPts val="0"/>
+              </a:spcBef>
+              <a:spcAft>
+                <a:spcPts val="0"/>
+              </a:spcAft>
+              <a:buClr>
+                <a:schemeClr val="dk1"/>
+              </a:buClr>
+              <a:buSzPts val="1100"/>
+              <a:buChar char="-"/>
+            </a:pPr>
+            <a:r>
+              <a:rPr lang="fr">
+                <a:solidFill>
+                  <a:schemeClr val="dk1"/>
+                </a:solidFill>
+              </a:rPr>
+              <a:t>dans ce contexte, l'accuracy ( (TP+TN)/Total et le ROC-AUC (courbe recall=TP/(TP+FN) vs taux de faux positifs FP/(TN+FN) ) sont trompeurs, car ils sont dominés par les vrais négatifs (TN), très nombreux qui dilue le reste.</a:t>
+            </a:r>
+            <a:endParaRPr>
+              <a:solidFill>
+                <a:schemeClr val="dk1"/>
+              </a:solidFill>
+            </a:endParaRPr>
+          </a:p>
+          <a:p>
+            <a:pPr indent="-298450" lvl="0" marL="457200" rtl="0" algn="l">
+              <a:spcBef>
+                <a:spcPts val="0"/>
+              </a:spcBef>
+              <a:spcAft>
+                <a:spcPts val="0"/>
+              </a:spcAft>
+              <a:buClr>
+                <a:schemeClr val="dk1"/>
+              </a:buClr>
+              <a:buSzPts val="1100"/>
+              <a:buChar char="-"/>
+            </a:pPr>
+            <a:r>
+              <a:rPr lang="fr">
+                <a:solidFill>
+                  <a:schemeClr val="dk1"/>
+                </a:solidFill>
+              </a:rPr>
+              <a:t>On le voit sur nos résultats : XGBoost a un ROC-AUC=0.997 quasi-parfait mais précision=TP/(TP+FP)=0.25 seulement au seuil par défaut — 3/4 alertes sont de fausses alertes (FP).</a:t>
+            </a:r>
+            <a:endParaRPr>
+              <a:solidFill>
+                <a:schemeClr val="dk1"/>
+              </a:solidFill>
+            </a:endParaRPr>
+          </a:p>
+          <a:p>
+            <a:pPr indent="-298450" lvl="0" marL="457200" rtl="0" algn="l">
+              <a:spcBef>
+                <a:spcPts val="0"/>
+              </a:spcBef>
+              <a:spcAft>
+                <a:spcPts val="0"/>
+              </a:spcAft>
+              <a:buClr>
+                <a:schemeClr val="dk1"/>
+              </a:buClr>
+              <a:buSzPts val="1100"/>
+              <a:buChar char="-"/>
+            </a:pPr>
+            <a:r>
+              <a:rPr lang="fr">
+                <a:solidFill>
+                  <a:schemeClr val="dk1"/>
+                </a:solidFill>
+              </a:rPr>
+              <a:t>Le PR-AUC (aire sous la courbe precision-recall) se concentre uniquement sur la classe positive (la fraude) et résume la performance du modèle sur tous les seuils de décision possibles, pas un seul. </a:t>
+            </a:r>
+            <a:endParaRPr>
+              <a:solidFill>
+                <a:schemeClr val="dk1"/>
+              </a:solidFill>
+            </a:endParaRPr>
+          </a:p>
+          <a:p>
+            <a:pPr indent="-298450" lvl="1" marL="914400" rtl="0" algn="l">
+              <a:spcBef>
+                <a:spcPts val="0"/>
+              </a:spcBef>
+              <a:spcAft>
+                <a:spcPts val="0"/>
+              </a:spcAft>
+              <a:buClr>
+                <a:schemeClr val="dk1"/>
+              </a:buClr>
+              <a:buSzPts val="1100"/>
+              <a:buChar char="-"/>
+            </a:pPr>
+            <a:r>
+              <a:rPr lang="fr">
+                <a:solidFill>
+                  <a:schemeClr val="dk1"/>
+                </a:solidFill>
+              </a:rPr>
+              <a:t>essentiel ici car F1/precision/recall dépendent fortement du seuil choisi</a:t>
+            </a:r>
+            <a:endParaRPr>
+              <a:solidFill>
+                <a:schemeClr val="dk1"/>
+              </a:solidFill>
+            </a:endParaRPr>
+          </a:p>
+          <a:p>
+            <a:pPr indent="-298450" lvl="1" marL="914400" rtl="0" algn="l">
+              <a:spcBef>
+                <a:spcPts val="0"/>
+              </a:spcBef>
+              <a:spcAft>
+                <a:spcPts val="0"/>
+              </a:spcAft>
+              <a:buClr>
+                <a:schemeClr val="dk1"/>
+              </a:buClr>
+              <a:buSzPts val="1100"/>
+              <a:buChar char="-"/>
+            </a:pPr>
+            <a:r>
+              <a:rPr lang="fr">
+                <a:solidFill>
+                  <a:schemeClr val="dk1"/>
+                </a:solidFill>
+              </a:rPr>
+              <a:t>le tableau le montre bien : XGBoost et LightGBM ont un PR-AUC proche (0.84 vs 0.86), mais des F1 très différents (0.40 vs 0.77) au même seuil de 0.5, simplement parce que leurs courbes precision-recall ont des formes différentes.</a:t>
+            </a:r>
+            <a:endParaRPr>
+              <a:solidFill>
+                <a:schemeClr val="dk1"/>
+              </a:solidFill>
+            </a:endParaRPr>
+          </a:p>
+          <a:p>
+            <a:pPr indent="0" lvl="0" marL="0" rtl="0" algn="l">
+              <a:spcBef>
+                <a:spcPts val="0"/>
+              </a:spcBef>
+              <a:spcAft>
+                <a:spcPts val="0"/>
+              </a:spcAft>
+              <a:buNone/>
+            </a:pPr>
+            <a:r>
+              <a:t/>
+            </a:r>
+            <a:endParaRPr>
+              <a:solidFill>
+                <a:schemeClr val="dk1"/>
+              </a:solidFill>
+            </a:endParaRPr>
+          </a:p>
+          <a:p>
+            <a:pPr indent="0" lvl="0" marL="0" rtl="0" algn="l">
+              <a:spcBef>
+                <a:spcPts val="0"/>
+              </a:spcBef>
+              <a:spcAft>
+                <a:spcPts val="0"/>
+              </a:spcAft>
+              <a:buNone/>
+            </a:pPr>
+            <a:r>
+              <a:rPr lang="fr">
+                <a:solidFill>
+                  <a:schemeClr val="dk1"/>
+                </a:solidFill>
+              </a:rPr>
+              <a:t>En résumé : PR-AUC sert à comparer et sélectionner les modèles (indépendant du seuil, focalisé sur la classe rare) ; F1/precision/recall serviront ensuite à choisir le seuil opérationnel une fois le modèle retenu, selon le compromis souhaité entre fausses alertes et fraudes manquées.</a:t>
+            </a:r>
+            <a:endParaRPr/>
+          </a:p>
+        </p:txBody>
+      </p:sp>
+    </p:spTree>
+  </p:cSld>
+  <p:clrMapOvr>
+    <a:masterClrMapping/>
+  </p:clrMapOvr>
+</p:notes>
+</file>
+
+<file path=ppt/notesSlides/notesSlide16.xml><?xml version="1.0" encoding="utf-8"?>
+<p:notes xmlns:a="http://schemas.openxmlformats.org/drawingml/2006/main" xmlns:r="http://schemas.openxmlformats.org/officeDocument/2006/relationships" xmlns:mc="http://schemas.openxmlformats.org/markup-compatibility/2006" xmlns:mv="urn:schemas-microsoft-com:mac:vml" xmlns:p="http://schemas.openxmlformats.org/presentationml/2006/main" xmlns:c="http://schemas.openxmlformats.org/drawingml/2006/chart" xmlns:dgm="http://schemas.openxmlformats.org/drawingml/2006/diagram" xmlns:o="urn:schemas-microsoft-com:office:office" xmlns:v="urn:schemas-microsoft-com:vml" xmlns:pvml="urn:schemas-microsoft-com:office:powerpoint" xmlns:com="http://schemas.openxmlformats.org/drawingml/2006/compatibility" xmlns:p14="http://schemas.microsoft.com/office/powerpoint/2010/main" xmlns:p15="http://schemas.microsoft.com/office/powerpoint/2012/main" xmlns:ahyp="http://schemas.microsoft.com/office/drawing/2018/hyperlinkcolor" showMasterPhAnim="0" showMasterSp="0">
+  <p:cSld>
+    <p:spTree>
+      <p:nvGrpSpPr>
+        <p:cNvPr id="185" name="Shape 185"/>
+        <p:cNvGrpSpPr/>
+        <p:nvPr/>
+      </p:nvGrpSpPr>
+      <p:grpSpPr>
+        <a:xfrm>
+          <a:off x="0" y="0"/>
+          <a:ext cx="0" cy="0"/>
+          <a:chOff x="0" y="0"/>
+          <a:chExt cx="0" cy="0"/>
+        </a:xfrm>
+      </p:grpSpPr>
+      <p:sp>
+        <p:nvSpPr>
+          <p:cNvPr id="186" name="Google Shape;186;g3f0fa6fd511_0_8:notes"/>
+          <p:cNvSpPr/>
+          <p:nvPr>
+            <p:ph idx="2" type="sldImg"/>
+          </p:nvPr>
+        </p:nvSpPr>
+        <p:spPr>
+          <a:xfrm>
+            <a:off x="381300" y="685800"/>
+            <a:ext cx="6096000" cy="3429000"/>
+          </a:xfrm>
+          <a:custGeom>
+            <a:rect b="b" l="l" r="r" t="t"/>
+            <a:pathLst>
+              <a:path extrusionOk="0" h="120000" w="120000">
+                <a:moveTo>
+                  <a:pt x="0" y="0"/>
+                </a:moveTo>
+                <a:lnTo>
+                  <a:pt x="120000" y="0"/>
+                </a:lnTo>
+                <a:lnTo>
+                  <a:pt x="120000" y="120000"/>
+                </a:lnTo>
+                <a:lnTo>
+                  <a:pt x="0" y="120000"/>
+                </a:lnTo>
+                <a:close/>
+              </a:path>
+            </a:pathLst>
+          </a:custGeom>
+        </p:spPr>
+      </p:sp>
+      <p:sp>
+        <p:nvSpPr>
+          <p:cNvPr id="187" name="Google Shape;187;g3f0fa6fd511_0_8:notes"/>
           <p:cNvSpPr txBox="1"/>
           <p:nvPr>
             <p:ph idx="1" type="body"/>
@@ -9020,7 +9536,7 @@
     <p:bg>
       <p:bgPr>
         <a:solidFill>
-          <a:srgbClr val="741B47"/>
+          <a:schemeClr val="lt1"/>
         </a:solidFill>
       </p:bgPr>
     </p:bg>
@@ -9041,6 +9557,1251 @@
       <p:sp>
         <p:nvSpPr>
           <p:cNvPr id="162" name="Google Shape;162;p25"/>
+          <p:cNvSpPr/>
+          <p:nvPr/>
+        </p:nvSpPr>
+        <p:spPr>
+          <a:xfrm>
+            <a:off x="0" y="0"/>
+            <a:ext cx="9145200" cy="720000"/>
+          </a:xfrm>
+          <a:prstGeom prst="rect">
+            <a:avLst/>
+          </a:prstGeom>
+          <a:solidFill>
+            <a:srgbClr val="A64D79"/>
+          </a:solidFill>
+          <a:ln cap="flat" cmpd="sng" w="9525">
+            <a:solidFill>
+              <a:schemeClr val="dk2"/>
+            </a:solidFill>
+            <a:prstDash val="solid"/>
+            <a:round/>
+            <a:headEnd len="sm" w="sm" type="none"/>
+            <a:tailEnd len="sm" w="sm" type="none"/>
+          </a:ln>
+        </p:spPr>
+        <p:txBody>
+          <a:bodyPr anchorCtr="0" anchor="ctr" bIns="91425" lIns="91425" spcFirstLastPara="1" rIns="91425" wrap="square" tIns="91425">
+            <a:noAutofit/>
+          </a:bodyPr>
+          <a:lstStyle/>
+          <a:p>
+            <a:pPr indent="0" lvl="0" marL="0" rtl="0" algn="ctr">
+              <a:spcBef>
+                <a:spcPts val="0"/>
+              </a:spcBef>
+              <a:spcAft>
+                <a:spcPts val="0"/>
+              </a:spcAft>
+              <a:buNone/>
+            </a:pPr>
+            <a:r>
+              <a:t/>
+            </a:r>
+            <a:endParaRPr/>
+          </a:p>
+        </p:txBody>
+      </p:sp>
+      <p:sp>
+        <p:nvSpPr>
+          <p:cNvPr id="163" name="Google Shape;163;p25"/>
+          <p:cNvSpPr txBox="1"/>
+          <p:nvPr/>
+        </p:nvSpPr>
+        <p:spPr>
+          <a:xfrm>
+            <a:off x="365400" y="2525"/>
+            <a:ext cx="8454600" cy="720000"/>
+          </a:xfrm>
+          <a:prstGeom prst="rect">
+            <a:avLst/>
+          </a:prstGeom>
+          <a:solidFill>
+            <a:srgbClr val="A64D79"/>
+          </a:solidFill>
+          <a:ln>
+            <a:noFill/>
+          </a:ln>
+        </p:spPr>
+        <p:txBody>
+          <a:bodyPr anchorCtr="0" anchor="t" bIns="91425" lIns="91425" spcFirstLastPara="1" rIns="91425" wrap="square" tIns="162000">
+            <a:noAutofit/>
+          </a:bodyPr>
+          <a:lstStyle/>
+          <a:p>
+            <a:pPr indent="0" lvl="0" marL="0" rtl="0" algn="l">
+              <a:spcBef>
+                <a:spcPts val="0"/>
+              </a:spcBef>
+              <a:spcAft>
+                <a:spcPts val="0"/>
+              </a:spcAft>
+              <a:buNone/>
+            </a:pPr>
+            <a:r>
+              <a:rPr lang="fr" sz="2400">
+                <a:solidFill>
+                  <a:schemeClr val="lt1"/>
+                </a:solidFill>
+                <a:latin typeface="Roboto Light"/>
+                <a:ea typeface="Roboto Light"/>
+                <a:cs typeface="Roboto Light"/>
+                <a:sym typeface="Roboto Light"/>
+              </a:rPr>
+              <a:t>Démonstration : Email alerte et rapport</a:t>
+            </a:r>
+            <a:endParaRPr sz="2400">
+              <a:solidFill>
+                <a:schemeClr val="lt1"/>
+              </a:solidFill>
+              <a:latin typeface="Roboto Light"/>
+              <a:ea typeface="Roboto Light"/>
+              <a:cs typeface="Roboto Light"/>
+              <a:sym typeface="Roboto Light"/>
+            </a:endParaRPr>
+          </a:p>
+        </p:txBody>
+      </p:sp>
+      <p:sp>
+        <p:nvSpPr>
+          <p:cNvPr id="164" name="Google Shape;164;p25"/>
+          <p:cNvSpPr/>
+          <p:nvPr/>
+        </p:nvSpPr>
+        <p:spPr>
+          <a:xfrm>
+            <a:off x="-600" y="4774300"/>
+            <a:ext cx="9145200" cy="360000"/>
+          </a:xfrm>
+          <a:prstGeom prst="rect">
+            <a:avLst/>
+          </a:prstGeom>
+          <a:solidFill>
+            <a:srgbClr val="A64D79"/>
+          </a:solidFill>
+          <a:ln cap="flat" cmpd="sng" w="9525">
+            <a:solidFill>
+              <a:schemeClr val="dk2"/>
+            </a:solidFill>
+            <a:prstDash val="solid"/>
+            <a:round/>
+            <a:headEnd len="sm" w="sm" type="none"/>
+            <a:tailEnd len="sm" w="sm" type="none"/>
+          </a:ln>
+        </p:spPr>
+        <p:txBody>
+          <a:bodyPr anchorCtr="0" anchor="ctr" bIns="91425" lIns="91425" spcFirstLastPara="1" rIns="91425" wrap="square" tIns="91425">
+            <a:noAutofit/>
+          </a:bodyPr>
+          <a:lstStyle/>
+          <a:p>
+            <a:pPr indent="0" lvl="0" marL="0" rtl="0" algn="ctr">
+              <a:spcBef>
+                <a:spcPts val="0"/>
+              </a:spcBef>
+              <a:spcAft>
+                <a:spcPts val="0"/>
+              </a:spcAft>
+              <a:buNone/>
+            </a:pPr>
+            <a:r>
+              <a:t/>
+            </a:r>
+            <a:endParaRPr/>
+          </a:p>
+        </p:txBody>
+      </p:sp>
+      <p:sp>
+        <p:nvSpPr>
+          <p:cNvPr id="165" name="Google Shape;165;p25"/>
+          <p:cNvSpPr txBox="1"/>
+          <p:nvPr/>
+        </p:nvSpPr>
+        <p:spPr>
+          <a:xfrm>
+            <a:off x="365400" y="4774300"/>
+            <a:ext cx="8454600" cy="360000"/>
+          </a:xfrm>
+          <a:prstGeom prst="rect">
+            <a:avLst/>
+          </a:prstGeom>
+          <a:noFill/>
+          <a:ln>
+            <a:noFill/>
+          </a:ln>
+        </p:spPr>
+        <p:txBody>
+          <a:bodyPr anchorCtr="0" anchor="t" bIns="91425" lIns="91425" spcFirstLastPara="1" rIns="91425" wrap="square" tIns="91425">
+            <a:noAutofit/>
+          </a:bodyPr>
+          <a:lstStyle/>
+          <a:p>
+            <a:pPr indent="0" lvl="0" marL="0" rtl="0" algn="l">
+              <a:spcBef>
+                <a:spcPts val="0"/>
+              </a:spcBef>
+              <a:spcAft>
+                <a:spcPts val="0"/>
+              </a:spcAft>
+              <a:buNone/>
+            </a:pPr>
+            <a:r>
+              <a:rPr lang="fr" sz="1000">
+                <a:solidFill>
+                  <a:schemeClr val="lt1"/>
+                </a:solidFill>
+                <a:latin typeface="Calibri"/>
+                <a:ea typeface="Calibri"/>
+                <a:cs typeface="Calibri"/>
+                <a:sym typeface="Calibri"/>
+              </a:rPr>
+              <a:t>Jedha - Certification AIA - Bloc 3 - Guillaume VIEL - 16 juillet 2026</a:t>
+            </a:r>
+            <a:endParaRPr sz="1000">
+              <a:solidFill>
+                <a:schemeClr val="lt1"/>
+              </a:solidFill>
+              <a:latin typeface="Calibri"/>
+              <a:ea typeface="Calibri"/>
+              <a:cs typeface="Calibri"/>
+              <a:sym typeface="Calibri"/>
+            </a:endParaRPr>
+          </a:p>
+        </p:txBody>
+      </p:sp>
+      <p:pic>
+        <p:nvPicPr>
+          <p:cNvPr id="166" name="Google Shape;166;p25" title="alert_email.png"/>
+          <p:cNvPicPr preferRelativeResize="0"/>
+          <p:nvPr/>
+        </p:nvPicPr>
+        <p:blipFill>
+          <a:blip r:embed="rId3">
+            <a:alphaModFix/>
+          </a:blip>
+          <a:stretch>
+            <a:fillRect/>
+          </a:stretch>
+        </p:blipFill>
+        <p:spPr>
+          <a:xfrm>
+            <a:off x="152400" y="765625"/>
+            <a:ext cx="6910150" cy="3384250"/>
+          </a:xfrm>
+          <a:prstGeom prst="rect">
+            <a:avLst/>
+          </a:prstGeom>
+          <a:noFill/>
+          <a:ln>
+            <a:noFill/>
+          </a:ln>
+          <a:effectLst>
+            <a:outerShdw blurRad="171450" rotWithShape="0" algn="bl" dir="12420000" dist="95250">
+              <a:schemeClr val="dk2">
+                <a:alpha val="66000"/>
+              </a:schemeClr>
+            </a:outerShdw>
+          </a:effectLst>
+        </p:spPr>
+      </p:pic>
+      <p:pic>
+        <p:nvPicPr>
+          <p:cNvPr id="167" name="Google Shape;167;p25" title="fraud_report.png"/>
+          <p:cNvPicPr preferRelativeResize="0"/>
+          <p:nvPr/>
+        </p:nvPicPr>
+        <p:blipFill>
+          <a:blip r:embed="rId4">
+            <a:alphaModFix/>
+          </a:blip>
+          <a:stretch>
+            <a:fillRect/>
+          </a:stretch>
+        </p:blipFill>
+        <p:spPr>
+          <a:xfrm>
+            <a:off x="4299875" y="1171600"/>
+            <a:ext cx="4772250" cy="3813675"/>
+          </a:xfrm>
+          <a:prstGeom prst="rect">
+            <a:avLst/>
+          </a:prstGeom>
+          <a:noFill/>
+          <a:ln>
+            <a:noFill/>
+          </a:ln>
+          <a:effectLst>
+            <a:outerShdw blurRad="171450" rotWithShape="0" algn="bl" dir="12420000" dist="95250">
+              <a:schemeClr val="dk2">
+                <a:alpha val="79000"/>
+              </a:schemeClr>
+            </a:outerShdw>
+          </a:effectLst>
+        </p:spPr>
+      </p:pic>
+    </p:spTree>
+  </p:cSld>
+  <p:clrMapOvr>
+    <a:masterClrMapping/>
+  </p:clrMapOvr>
+</p:sld>
+</file>
+
+<file path=ppt/slides/slide14.xml><?xml version="1.0" encoding="utf-8"?>
+<p:sld xmlns:a="http://schemas.openxmlformats.org/drawingml/2006/main" xmlns:r="http://schemas.openxmlformats.org/officeDocument/2006/relationships" xmlns:mc="http://schemas.openxmlformats.org/markup-compatibility/2006" xmlns:mv="urn:schemas-microsoft-com:mac:vml" xmlns:p="http://schemas.openxmlformats.org/presentationml/2006/main" xmlns:c="http://schemas.openxmlformats.org/drawingml/2006/chart" xmlns:dgm="http://schemas.openxmlformats.org/drawingml/2006/diagram" xmlns:o="urn:schemas-microsoft-com:office:office" xmlns:v="urn:schemas-microsoft-com:vml" xmlns:pvml="urn:schemas-microsoft-com:office:powerpoint" xmlns:com="http://schemas.openxmlformats.org/drawingml/2006/compatibility" xmlns:p14="http://schemas.microsoft.com/office/powerpoint/2010/main" xmlns:p15="http://schemas.microsoft.com/office/powerpoint/2012/main" xmlns:ahyp="http://schemas.microsoft.com/office/drawing/2018/hyperlinkcolor">
+  <p:cSld>
+    <p:bg>
+      <p:bgPr>
+        <a:solidFill>
+          <a:srgbClr val="741B47"/>
+        </a:solidFill>
+      </p:bgPr>
+    </p:bg>
+    <p:spTree>
+      <p:nvGrpSpPr>
+        <p:cNvPr id="171" name="Shape 171"/>
+        <p:cNvGrpSpPr/>
+        <p:nvPr/>
+      </p:nvGrpSpPr>
+      <p:grpSpPr>
+        <a:xfrm>
+          <a:off x="0" y="0"/>
+          <a:ext cx="0" cy="0"/>
+          <a:chOff x="0" y="0"/>
+          <a:chExt cx="0" cy="0"/>
+        </a:xfrm>
+      </p:grpSpPr>
+      <p:sp>
+        <p:nvSpPr>
+          <p:cNvPr id="172" name="Google Shape;172;p26"/>
+          <p:cNvSpPr/>
+          <p:nvPr/>
+        </p:nvSpPr>
+        <p:spPr>
+          <a:xfrm>
+            <a:off x="0" y="0"/>
+            <a:ext cx="9145200" cy="720000"/>
+          </a:xfrm>
+          <a:prstGeom prst="rect">
+            <a:avLst/>
+          </a:prstGeom>
+          <a:solidFill>
+            <a:srgbClr val="741B47"/>
+          </a:solidFill>
+          <a:ln cap="flat" cmpd="sng" w="9525">
+            <a:solidFill>
+              <a:schemeClr val="dk2"/>
+            </a:solidFill>
+            <a:prstDash val="solid"/>
+            <a:round/>
+            <a:headEnd len="sm" w="sm" type="none"/>
+            <a:tailEnd len="sm" w="sm" type="none"/>
+          </a:ln>
+        </p:spPr>
+        <p:txBody>
+          <a:bodyPr anchorCtr="0" anchor="ctr" bIns="91425" lIns="91425" spcFirstLastPara="1" rIns="91425" wrap="square" tIns="91425">
+            <a:noAutofit/>
+          </a:bodyPr>
+          <a:lstStyle/>
+          <a:p>
+            <a:pPr indent="0" lvl="0" marL="0" rtl="0" algn="ctr">
+              <a:spcBef>
+                <a:spcPts val="0"/>
+              </a:spcBef>
+              <a:spcAft>
+                <a:spcPts val="0"/>
+              </a:spcAft>
+              <a:buNone/>
+            </a:pPr>
+            <a:r>
+              <a:t/>
+            </a:r>
+            <a:endParaRPr/>
+          </a:p>
+        </p:txBody>
+      </p:sp>
+      <p:sp>
+        <p:nvSpPr>
+          <p:cNvPr id="173" name="Google Shape;173;p26"/>
+          <p:cNvSpPr txBox="1"/>
+          <p:nvPr/>
+        </p:nvSpPr>
+        <p:spPr>
+          <a:xfrm>
+            <a:off x="302850" y="2035551"/>
+            <a:ext cx="8454600" cy="1002300"/>
+          </a:xfrm>
+          <a:prstGeom prst="rect">
+            <a:avLst/>
+          </a:prstGeom>
+          <a:noFill/>
+          <a:ln>
+            <a:noFill/>
+          </a:ln>
+        </p:spPr>
+        <p:txBody>
+          <a:bodyPr anchorCtr="0" anchor="t" bIns="91425" lIns="91425" spcFirstLastPara="1" rIns="91425" wrap="square" tIns="162000">
+            <a:noAutofit/>
+          </a:bodyPr>
+          <a:lstStyle/>
+          <a:p>
+            <a:pPr indent="0" lvl="0" marL="0" rtl="0" algn="ctr">
+              <a:spcBef>
+                <a:spcPts val="0"/>
+              </a:spcBef>
+              <a:spcAft>
+                <a:spcPts val="0"/>
+              </a:spcAft>
+              <a:buNone/>
+            </a:pPr>
+            <a:r>
+              <a:rPr b="1" lang="fr" sz="2400">
+                <a:solidFill>
+                  <a:schemeClr val="lt1"/>
+                </a:solidFill>
+                <a:latin typeface="Roboto"/>
+                <a:ea typeface="Roboto"/>
+                <a:cs typeface="Roboto"/>
+                <a:sym typeface="Roboto"/>
+              </a:rPr>
+              <a:t>Conclusion</a:t>
+            </a:r>
+            <a:endParaRPr b="1" sz="2400">
+              <a:solidFill>
+                <a:schemeClr val="lt1"/>
+              </a:solidFill>
+              <a:latin typeface="Roboto"/>
+              <a:ea typeface="Roboto"/>
+              <a:cs typeface="Roboto"/>
+              <a:sym typeface="Roboto"/>
+            </a:endParaRPr>
+          </a:p>
+        </p:txBody>
+      </p:sp>
+      <p:sp>
+        <p:nvSpPr>
+          <p:cNvPr id="174" name="Google Shape;174;p26"/>
+          <p:cNvSpPr/>
+          <p:nvPr/>
+        </p:nvSpPr>
+        <p:spPr>
+          <a:xfrm>
+            <a:off x="-600" y="4774300"/>
+            <a:ext cx="9145200" cy="360000"/>
+          </a:xfrm>
+          <a:prstGeom prst="rect">
+            <a:avLst/>
+          </a:prstGeom>
+          <a:solidFill>
+            <a:srgbClr val="741B47"/>
+          </a:solidFill>
+          <a:ln cap="flat" cmpd="sng" w="9525">
+            <a:solidFill>
+              <a:schemeClr val="dk2"/>
+            </a:solidFill>
+            <a:prstDash val="solid"/>
+            <a:round/>
+            <a:headEnd len="sm" w="sm" type="none"/>
+            <a:tailEnd len="sm" w="sm" type="none"/>
+          </a:ln>
+        </p:spPr>
+        <p:txBody>
+          <a:bodyPr anchorCtr="0" anchor="ctr" bIns="91425" lIns="91425" spcFirstLastPara="1" rIns="91425" wrap="square" tIns="91425">
+            <a:noAutofit/>
+          </a:bodyPr>
+          <a:lstStyle/>
+          <a:p>
+            <a:pPr indent="0" lvl="0" marL="0" rtl="0" algn="ctr">
+              <a:spcBef>
+                <a:spcPts val="0"/>
+              </a:spcBef>
+              <a:spcAft>
+                <a:spcPts val="0"/>
+              </a:spcAft>
+              <a:buNone/>
+            </a:pPr>
+            <a:r>
+              <a:t/>
+            </a:r>
+            <a:endParaRPr/>
+          </a:p>
+        </p:txBody>
+      </p:sp>
+      <p:sp>
+        <p:nvSpPr>
+          <p:cNvPr id="175" name="Google Shape;175;p26"/>
+          <p:cNvSpPr txBox="1"/>
+          <p:nvPr/>
+        </p:nvSpPr>
+        <p:spPr>
+          <a:xfrm>
+            <a:off x="365400" y="4774300"/>
+            <a:ext cx="8454600" cy="360000"/>
+          </a:xfrm>
+          <a:prstGeom prst="rect">
+            <a:avLst/>
+          </a:prstGeom>
+          <a:solidFill>
+            <a:srgbClr val="741B47"/>
+          </a:solidFill>
+          <a:ln>
+            <a:noFill/>
+          </a:ln>
+        </p:spPr>
+        <p:txBody>
+          <a:bodyPr anchorCtr="0" anchor="t" bIns="91425" lIns="91425" spcFirstLastPara="1" rIns="91425" wrap="square" tIns="91425">
+            <a:noAutofit/>
+          </a:bodyPr>
+          <a:lstStyle/>
+          <a:p>
+            <a:pPr indent="0" lvl="0" marL="0" rtl="0" algn="l">
+              <a:spcBef>
+                <a:spcPts val="0"/>
+              </a:spcBef>
+              <a:spcAft>
+                <a:spcPts val="0"/>
+              </a:spcAft>
+              <a:buNone/>
+            </a:pPr>
+            <a:r>
+              <a:rPr lang="fr" sz="1000">
+                <a:solidFill>
+                  <a:schemeClr val="lt1"/>
+                </a:solidFill>
+                <a:latin typeface="Calibri"/>
+                <a:ea typeface="Calibri"/>
+                <a:cs typeface="Calibri"/>
+                <a:sym typeface="Calibri"/>
+              </a:rPr>
+              <a:t>Jedha - Certification AIA - Bloc 3 - Guillaume VIEL - 16 juillet 2026</a:t>
+            </a:r>
+            <a:endParaRPr sz="1000">
+              <a:solidFill>
+                <a:schemeClr val="lt1"/>
+              </a:solidFill>
+              <a:latin typeface="Calibri"/>
+              <a:ea typeface="Calibri"/>
+              <a:cs typeface="Calibri"/>
+              <a:sym typeface="Calibri"/>
+            </a:endParaRPr>
+          </a:p>
+        </p:txBody>
+      </p:sp>
+    </p:spTree>
+  </p:cSld>
+  <p:clrMapOvr>
+    <a:masterClrMapping/>
+  </p:clrMapOvr>
+</p:sld>
+</file>
+
+<file path=ppt/slides/slide15.xml><?xml version="1.0" encoding="utf-8"?>
+<p:sld xmlns:a="http://schemas.openxmlformats.org/drawingml/2006/main" xmlns:r="http://schemas.openxmlformats.org/officeDocument/2006/relationships" xmlns:mc="http://schemas.openxmlformats.org/markup-compatibility/2006" xmlns:mv="urn:schemas-microsoft-com:mac:vml" xmlns:p="http://schemas.openxmlformats.org/presentationml/2006/main" xmlns:c="http://schemas.openxmlformats.org/drawingml/2006/chart" xmlns:dgm="http://schemas.openxmlformats.org/drawingml/2006/diagram" xmlns:o="urn:schemas-microsoft-com:office:office" xmlns:v="urn:schemas-microsoft-com:vml" xmlns:pvml="urn:schemas-microsoft-com:office:powerpoint" xmlns:com="http://schemas.openxmlformats.org/drawingml/2006/compatibility" xmlns:p14="http://schemas.microsoft.com/office/powerpoint/2010/main" xmlns:p15="http://schemas.microsoft.com/office/powerpoint/2012/main" xmlns:ahyp="http://schemas.microsoft.com/office/drawing/2018/hyperlinkcolor">
+  <p:cSld>
+    <p:bg>
+      <p:bgPr>
+        <a:solidFill>
+          <a:schemeClr val="lt1"/>
+        </a:solidFill>
+      </p:bgPr>
+    </p:bg>
+    <p:spTree>
+      <p:nvGrpSpPr>
+        <p:cNvPr id="179" name="Shape 179"/>
+        <p:cNvGrpSpPr/>
+        <p:nvPr/>
+      </p:nvGrpSpPr>
+      <p:grpSpPr>
+        <a:xfrm>
+          <a:off x="0" y="0"/>
+          <a:ext cx="0" cy="0"/>
+          <a:chOff x="0" y="0"/>
+          <a:chExt cx="0" cy="0"/>
+        </a:xfrm>
+      </p:grpSpPr>
+      <p:sp>
+        <p:nvSpPr>
+          <p:cNvPr id="180" name="Google Shape;180;p27"/>
+          <p:cNvSpPr/>
+          <p:nvPr/>
+        </p:nvSpPr>
+        <p:spPr>
+          <a:xfrm>
+            <a:off x="0" y="0"/>
+            <a:ext cx="9145200" cy="720000"/>
+          </a:xfrm>
+          <a:prstGeom prst="rect">
+            <a:avLst/>
+          </a:prstGeom>
+          <a:solidFill>
+            <a:srgbClr val="A64D79"/>
+          </a:solidFill>
+          <a:ln cap="flat" cmpd="sng" w="9525">
+            <a:solidFill>
+              <a:schemeClr val="dk2"/>
+            </a:solidFill>
+            <a:prstDash val="solid"/>
+            <a:round/>
+            <a:headEnd len="sm" w="sm" type="none"/>
+            <a:tailEnd len="sm" w="sm" type="none"/>
+          </a:ln>
+        </p:spPr>
+        <p:txBody>
+          <a:bodyPr anchorCtr="0" anchor="ctr" bIns="91425" lIns="91425" spcFirstLastPara="1" rIns="91425" wrap="square" tIns="91425">
+            <a:noAutofit/>
+          </a:bodyPr>
+          <a:lstStyle/>
+          <a:p>
+            <a:pPr indent="0" lvl="0" marL="0" rtl="0" algn="ctr">
+              <a:spcBef>
+                <a:spcPts val="0"/>
+              </a:spcBef>
+              <a:spcAft>
+                <a:spcPts val="0"/>
+              </a:spcAft>
+              <a:buNone/>
+            </a:pPr>
+            <a:r>
+              <a:t/>
+            </a:r>
+            <a:endParaRPr/>
+          </a:p>
+        </p:txBody>
+      </p:sp>
+      <p:sp>
+        <p:nvSpPr>
+          <p:cNvPr id="181" name="Google Shape;181;p27"/>
+          <p:cNvSpPr txBox="1"/>
+          <p:nvPr/>
+        </p:nvSpPr>
+        <p:spPr>
+          <a:xfrm>
+            <a:off x="365400" y="2525"/>
+            <a:ext cx="8454600" cy="720000"/>
+          </a:xfrm>
+          <a:prstGeom prst="rect">
+            <a:avLst/>
+          </a:prstGeom>
+          <a:solidFill>
+            <a:srgbClr val="A64D79"/>
+          </a:solidFill>
+          <a:ln>
+            <a:noFill/>
+          </a:ln>
+        </p:spPr>
+        <p:txBody>
+          <a:bodyPr anchorCtr="0" anchor="t" bIns="91425" lIns="91425" spcFirstLastPara="1" rIns="91425" wrap="square" tIns="162000">
+            <a:noAutofit/>
+          </a:bodyPr>
+          <a:lstStyle/>
+          <a:p>
+            <a:pPr indent="0" lvl="0" marL="0" rtl="0" algn="l">
+              <a:spcBef>
+                <a:spcPts val="0"/>
+              </a:spcBef>
+              <a:spcAft>
+                <a:spcPts val="0"/>
+              </a:spcAft>
+              <a:buNone/>
+            </a:pPr>
+            <a:r>
+              <a:rPr lang="fr" sz="2400">
+                <a:solidFill>
+                  <a:schemeClr val="lt1"/>
+                </a:solidFill>
+                <a:latin typeface="Roboto Light"/>
+                <a:ea typeface="Roboto Light"/>
+                <a:cs typeface="Roboto Light"/>
+                <a:sym typeface="Roboto Light"/>
+              </a:rPr>
+              <a:t>Conclusion</a:t>
+            </a:r>
+            <a:endParaRPr sz="2400">
+              <a:solidFill>
+                <a:schemeClr val="lt1"/>
+              </a:solidFill>
+              <a:latin typeface="Roboto Light"/>
+              <a:ea typeface="Roboto Light"/>
+              <a:cs typeface="Roboto Light"/>
+              <a:sym typeface="Roboto Light"/>
+            </a:endParaRPr>
+          </a:p>
+        </p:txBody>
+      </p:sp>
+      <p:sp>
+        <p:nvSpPr>
+          <p:cNvPr id="182" name="Google Shape;182;p27"/>
+          <p:cNvSpPr txBox="1"/>
+          <p:nvPr/>
+        </p:nvSpPr>
+        <p:spPr>
+          <a:xfrm>
+            <a:off x="194100" y="792662"/>
+            <a:ext cx="8755800" cy="3911400"/>
+          </a:xfrm>
+          <a:prstGeom prst="rect">
+            <a:avLst/>
+          </a:prstGeom>
+          <a:noFill/>
+          <a:ln>
+            <a:noFill/>
+          </a:ln>
+        </p:spPr>
+        <p:txBody>
+          <a:bodyPr anchorCtr="0" anchor="t" bIns="91425" lIns="91425" spcFirstLastPara="1" rIns="91425" wrap="square" tIns="91425">
+            <a:noAutofit/>
+          </a:bodyPr>
+          <a:lstStyle/>
+          <a:p>
+            <a:pPr indent="-349250" lvl="0" marL="457200" rtl="0" algn="l">
+              <a:spcBef>
+                <a:spcPts val="0"/>
+              </a:spcBef>
+              <a:spcAft>
+                <a:spcPts val="0"/>
+              </a:spcAft>
+              <a:buClr>
+                <a:schemeClr val="dk2"/>
+              </a:buClr>
+              <a:buSzPts val="1900"/>
+              <a:buFont typeface="Calibri"/>
+              <a:buChar char="●"/>
+            </a:pPr>
+            <a:r>
+              <a:rPr b="1" lang="fr" sz="1900">
+                <a:solidFill>
+                  <a:schemeClr val="dk2"/>
+                </a:solidFill>
+                <a:latin typeface="Calibri"/>
+                <a:ea typeface="Calibri"/>
+                <a:cs typeface="Calibri"/>
+                <a:sym typeface="Calibri"/>
+              </a:rPr>
+              <a:t>Difficultés</a:t>
+            </a:r>
+            <a:endParaRPr b="1" sz="1900">
+              <a:solidFill>
+                <a:schemeClr val="dk2"/>
+              </a:solidFill>
+              <a:latin typeface="Calibri"/>
+              <a:ea typeface="Calibri"/>
+              <a:cs typeface="Calibri"/>
+              <a:sym typeface="Calibri"/>
+            </a:endParaRPr>
+          </a:p>
+          <a:p>
+            <a:pPr indent="-349250" lvl="1" marL="914400" rtl="0" algn="l">
+              <a:spcBef>
+                <a:spcPts val="0"/>
+              </a:spcBef>
+              <a:spcAft>
+                <a:spcPts val="0"/>
+              </a:spcAft>
+              <a:buClr>
+                <a:schemeClr val="dk2"/>
+              </a:buClr>
+              <a:buSzPts val="1900"/>
+              <a:buFont typeface="Calibri"/>
+              <a:buChar char="○"/>
+            </a:pPr>
+            <a:r>
+              <a:rPr b="1" lang="fr" sz="1900">
+                <a:solidFill>
+                  <a:schemeClr val="dk2"/>
+                </a:solidFill>
+                <a:latin typeface="Calibri"/>
+                <a:ea typeface="Calibri"/>
+                <a:cs typeface="Calibri"/>
+                <a:sym typeface="Calibri"/>
+              </a:rPr>
+              <a:t>contraintes des free plan…</a:t>
+            </a:r>
+            <a:endParaRPr b="1" sz="1900">
+              <a:solidFill>
+                <a:schemeClr val="dk2"/>
+              </a:solidFill>
+              <a:latin typeface="Calibri"/>
+              <a:ea typeface="Calibri"/>
+              <a:cs typeface="Calibri"/>
+              <a:sym typeface="Calibri"/>
+            </a:endParaRPr>
+          </a:p>
+          <a:p>
+            <a:pPr indent="-349250" lvl="1" marL="914400" rtl="0" algn="l">
+              <a:spcBef>
+                <a:spcPts val="0"/>
+              </a:spcBef>
+              <a:spcAft>
+                <a:spcPts val="0"/>
+              </a:spcAft>
+              <a:buClr>
+                <a:schemeClr val="dk2"/>
+              </a:buClr>
+              <a:buSzPts val="1900"/>
+              <a:buFont typeface="Calibri"/>
+              <a:buChar char="○"/>
+            </a:pPr>
+            <a:r>
+              <a:rPr b="1" lang="fr" sz="1900">
+                <a:solidFill>
+                  <a:schemeClr val="dk2"/>
+                </a:solidFill>
+                <a:latin typeface="Calibri"/>
+                <a:ea typeface="Calibri"/>
+                <a:cs typeface="Calibri"/>
+                <a:sym typeface="Calibri"/>
+              </a:rPr>
+              <a:t>déploiement stack Airflow en local (complexe voire impossible sur HF ou Render)</a:t>
+            </a:r>
+            <a:endParaRPr b="1" sz="1900">
+              <a:solidFill>
+                <a:schemeClr val="dk2"/>
+              </a:solidFill>
+              <a:latin typeface="Calibri"/>
+              <a:ea typeface="Calibri"/>
+              <a:cs typeface="Calibri"/>
+              <a:sym typeface="Calibri"/>
+            </a:endParaRPr>
+          </a:p>
+          <a:p>
+            <a:pPr indent="-349250" lvl="1" marL="914400" rtl="0" algn="l">
+              <a:spcBef>
+                <a:spcPts val="0"/>
+              </a:spcBef>
+              <a:spcAft>
+                <a:spcPts val="0"/>
+              </a:spcAft>
+              <a:buClr>
+                <a:schemeClr val="dk2"/>
+              </a:buClr>
+              <a:buSzPts val="1900"/>
+              <a:buFont typeface="Calibri"/>
+              <a:buChar char="○"/>
+            </a:pPr>
+            <a:r>
+              <a:rPr b="1" lang="fr" sz="1900">
+                <a:solidFill>
+                  <a:schemeClr val="dk2"/>
+                </a:solidFill>
+                <a:latin typeface="Calibri"/>
+                <a:ea typeface="Calibri"/>
+                <a:cs typeface="Calibri"/>
+                <a:sym typeface="Calibri"/>
+              </a:rPr>
+              <a:t>nombreux modules et nombreuses vars de config</a:t>
+            </a:r>
+            <a:br>
+              <a:rPr b="1" lang="fr" sz="1900">
+                <a:solidFill>
+                  <a:schemeClr val="dk2"/>
+                </a:solidFill>
+                <a:latin typeface="Calibri"/>
+                <a:ea typeface="Calibri"/>
+                <a:cs typeface="Calibri"/>
+                <a:sym typeface="Calibri"/>
+              </a:rPr>
+            </a:br>
+            <a:endParaRPr b="1" sz="1900">
+              <a:solidFill>
+                <a:schemeClr val="dk2"/>
+              </a:solidFill>
+              <a:latin typeface="Calibri"/>
+              <a:ea typeface="Calibri"/>
+              <a:cs typeface="Calibri"/>
+              <a:sym typeface="Calibri"/>
+            </a:endParaRPr>
+          </a:p>
+          <a:p>
+            <a:pPr indent="-349250" lvl="0" marL="457200" rtl="0" algn="l">
+              <a:spcBef>
+                <a:spcPts val="0"/>
+              </a:spcBef>
+              <a:spcAft>
+                <a:spcPts val="0"/>
+              </a:spcAft>
+              <a:buClr>
+                <a:schemeClr val="dk2"/>
+              </a:buClr>
+              <a:buSzPts val="1900"/>
+              <a:buFont typeface="Calibri"/>
+              <a:buChar char="●"/>
+            </a:pPr>
+            <a:r>
+              <a:rPr b="1" lang="fr" sz="1900">
+                <a:solidFill>
+                  <a:schemeClr val="dk2"/>
+                </a:solidFill>
+                <a:latin typeface="Calibri"/>
+                <a:ea typeface="Calibri"/>
+                <a:cs typeface="Calibri"/>
+                <a:sym typeface="Calibri"/>
+              </a:rPr>
+              <a:t>Améliorations</a:t>
+            </a:r>
+            <a:endParaRPr b="1" sz="1900">
+              <a:solidFill>
+                <a:schemeClr val="dk2"/>
+              </a:solidFill>
+              <a:latin typeface="Calibri"/>
+              <a:ea typeface="Calibri"/>
+              <a:cs typeface="Calibri"/>
+              <a:sym typeface="Calibri"/>
+            </a:endParaRPr>
+          </a:p>
+          <a:p>
+            <a:pPr indent="-349250" lvl="1" marL="914400" rtl="0" algn="l">
+              <a:spcBef>
+                <a:spcPts val="0"/>
+              </a:spcBef>
+              <a:spcAft>
+                <a:spcPts val="0"/>
+              </a:spcAft>
+              <a:buClr>
+                <a:schemeClr val="dk2"/>
+              </a:buClr>
+              <a:buSzPts val="1900"/>
+              <a:buFont typeface="Calibri"/>
+              <a:buChar char="○"/>
+            </a:pPr>
+            <a:r>
+              <a:rPr b="1" lang="fr" sz="1900">
+                <a:solidFill>
+                  <a:schemeClr val="dk2"/>
+                </a:solidFill>
+                <a:latin typeface="Calibri"/>
+                <a:ea typeface="Calibri"/>
+                <a:cs typeface="Calibri"/>
+                <a:sym typeface="Calibri"/>
+              </a:rPr>
+              <a:t>déploiement du training sur EC2 ou équivalent (type Openstack)</a:t>
+            </a:r>
+            <a:endParaRPr b="1" sz="1900">
+              <a:solidFill>
+                <a:schemeClr val="dk2"/>
+              </a:solidFill>
+              <a:latin typeface="Calibri"/>
+              <a:ea typeface="Calibri"/>
+              <a:cs typeface="Calibri"/>
+              <a:sym typeface="Calibri"/>
+            </a:endParaRPr>
+          </a:p>
+          <a:p>
+            <a:pPr indent="-349250" lvl="1" marL="914400" rtl="0" algn="l">
+              <a:spcBef>
+                <a:spcPts val="0"/>
+              </a:spcBef>
+              <a:spcAft>
+                <a:spcPts val="0"/>
+              </a:spcAft>
+              <a:buClr>
+                <a:schemeClr val="dk2"/>
+              </a:buClr>
+              <a:buSzPts val="1900"/>
+              <a:buFont typeface="Calibri"/>
+              <a:buChar char="○"/>
+            </a:pPr>
+            <a:r>
+              <a:rPr b="1" lang="fr" sz="1900">
+                <a:solidFill>
+                  <a:schemeClr val="dk2"/>
+                </a:solidFill>
+                <a:latin typeface="Calibri"/>
+                <a:ea typeface="Calibri"/>
+                <a:cs typeface="Calibri"/>
+                <a:sym typeface="Calibri"/>
+              </a:rPr>
+              <a:t>ou K8s + Ray pour paralléliser les calculs de plusieurs modèles en </a:t>
+            </a:r>
+            <a:r>
+              <a:rPr b="1" lang="fr" sz="1900">
+                <a:solidFill>
+                  <a:schemeClr val="dk2"/>
+                </a:solidFill>
+                <a:latin typeface="Calibri"/>
+                <a:ea typeface="Calibri"/>
+                <a:cs typeface="Calibri"/>
+                <a:sym typeface="Calibri"/>
+              </a:rPr>
+              <a:t>même</a:t>
+            </a:r>
+            <a:r>
+              <a:rPr b="1" lang="fr" sz="1900">
+                <a:solidFill>
+                  <a:schemeClr val="dk2"/>
+                </a:solidFill>
+                <a:latin typeface="Calibri"/>
+                <a:ea typeface="Calibri"/>
+                <a:cs typeface="Calibri"/>
+                <a:sym typeface="Calibri"/>
+              </a:rPr>
+              <a:t> temps</a:t>
+            </a:r>
+            <a:endParaRPr b="1" sz="1900">
+              <a:solidFill>
+                <a:schemeClr val="dk2"/>
+              </a:solidFill>
+              <a:latin typeface="Calibri"/>
+              <a:ea typeface="Calibri"/>
+              <a:cs typeface="Calibri"/>
+              <a:sym typeface="Calibri"/>
+            </a:endParaRPr>
+          </a:p>
+          <a:p>
+            <a:pPr indent="-349250" lvl="1" marL="914400" rtl="0" algn="l">
+              <a:spcBef>
+                <a:spcPts val="0"/>
+              </a:spcBef>
+              <a:spcAft>
+                <a:spcPts val="0"/>
+              </a:spcAft>
+              <a:buClr>
+                <a:schemeClr val="dk2"/>
+              </a:buClr>
+              <a:buSzPts val="1900"/>
+              <a:buFont typeface="Calibri"/>
+              <a:buChar char="○"/>
+            </a:pPr>
+            <a:r>
+              <a:rPr b="1" lang="fr" sz="1900">
+                <a:solidFill>
+                  <a:schemeClr val="dk2"/>
+                </a:solidFill>
+                <a:latin typeface="Calibri"/>
+                <a:ea typeface="Calibri"/>
+                <a:cs typeface="Calibri"/>
+                <a:sym typeface="Calibri"/>
+              </a:rPr>
+              <a:t>Kafka pour absorber des trx en temps réel (ici démesuré)</a:t>
+            </a:r>
+            <a:endParaRPr b="1" sz="1900">
+              <a:solidFill>
+                <a:schemeClr val="dk2"/>
+              </a:solidFill>
+              <a:latin typeface="Calibri"/>
+              <a:ea typeface="Calibri"/>
+              <a:cs typeface="Calibri"/>
+              <a:sym typeface="Calibri"/>
+            </a:endParaRPr>
+          </a:p>
+          <a:p>
+            <a:pPr indent="-349250" lvl="1" marL="914400" rtl="0" algn="l">
+              <a:spcBef>
+                <a:spcPts val="0"/>
+              </a:spcBef>
+              <a:spcAft>
+                <a:spcPts val="0"/>
+              </a:spcAft>
+              <a:buClr>
+                <a:schemeClr val="dk2"/>
+              </a:buClr>
+              <a:buSzPts val="1900"/>
+              <a:buFont typeface="Calibri"/>
+              <a:buChar char="○"/>
+            </a:pPr>
+            <a:r>
+              <a:rPr b="1" lang="fr" sz="1900">
+                <a:solidFill>
+                  <a:schemeClr val="dk2"/>
+                </a:solidFill>
+                <a:latin typeface="Calibri"/>
+                <a:ea typeface="Calibri"/>
+                <a:cs typeface="Calibri"/>
+                <a:sym typeface="Calibri"/>
+              </a:rPr>
+              <a:t>rapport en PDF et stockage sur S3</a:t>
+            </a:r>
+            <a:endParaRPr b="1" sz="1900">
+              <a:solidFill>
+                <a:schemeClr val="dk2"/>
+              </a:solidFill>
+              <a:latin typeface="Calibri"/>
+              <a:ea typeface="Calibri"/>
+              <a:cs typeface="Calibri"/>
+              <a:sym typeface="Calibri"/>
+            </a:endParaRPr>
+          </a:p>
+          <a:p>
+            <a:pPr indent="-349250" lvl="1" marL="914400" rtl="0" algn="l">
+              <a:spcBef>
+                <a:spcPts val="0"/>
+              </a:spcBef>
+              <a:spcAft>
+                <a:spcPts val="0"/>
+              </a:spcAft>
+              <a:buClr>
+                <a:schemeClr val="dk2"/>
+              </a:buClr>
+              <a:buSzPts val="1900"/>
+              <a:buFont typeface="Calibri"/>
+              <a:buChar char="○"/>
+            </a:pPr>
+            <a:r>
+              <a:rPr b="1" lang="fr" sz="1900">
+                <a:solidFill>
+                  <a:schemeClr val="dk2"/>
+                </a:solidFill>
+                <a:latin typeface="Calibri"/>
+                <a:ea typeface="Calibri"/>
+                <a:cs typeface="Calibri"/>
+                <a:sym typeface="Calibri"/>
+              </a:rPr>
+              <a:t>sécurité…</a:t>
+            </a:r>
+            <a:endParaRPr b="1" sz="1900">
+              <a:solidFill>
+                <a:schemeClr val="dk2"/>
+              </a:solidFill>
+              <a:latin typeface="Calibri"/>
+              <a:ea typeface="Calibri"/>
+              <a:cs typeface="Calibri"/>
+              <a:sym typeface="Calibri"/>
+            </a:endParaRPr>
+          </a:p>
+        </p:txBody>
+      </p:sp>
+      <p:sp>
+        <p:nvSpPr>
+          <p:cNvPr id="183" name="Google Shape;183;p27"/>
+          <p:cNvSpPr/>
+          <p:nvPr/>
+        </p:nvSpPr>
+        <p:spPr>
+          <a:xfrm>
+            <a:off x="-600" y="4774300"/>
+            <a:ext cx="9145200" cy="360000"/>
+          </a:xfrm>
+          <a:prstGeom prst="rect">
+            <a:avLst/>
+          </a:prstGeom>
+          <a:solidFill>
+            <a:srgbClr val="A64D79"/>
+          </a:solidFill>
+          <a:ln cap="flat" cmpd="sng" w="9525">
+            <a:solidFill>
+              <a:schemeClr val="dk2"/>
+            </a:solidFill>
+            <a:prstDash val="solid"/>
+            <a:round/>
+            <a:headEnd len="sm" w="sm" type="none"/>
+            <a:tailEnd len="sm" w="sm" type="none"/>
+          </a:ln>
+        </p:spPr>
+        <p:txBody>
+          <a:bodyPr anchorCtr="0" anchor="ctr" bIns="91425" lIns="91425" spcFirstLastPara="1" rIns="91425" wrap="square" tIns="91425">
+            <a:noAutofit/>
+          </a:bodyPr>
+          <a:lstStyle/>
+          <a:p>
+            <a:pPr indent="0" lvl="0" marL="0" rtl="0" algn="ctr">
+              <a:spcBef>
+                <a:spcPts val="0"/>
+              </a:spcBef>
+              <a:spcAft>
+                <a:spcPts val="0"/>
+              </a:spcAft>
+              <a:buNone/>
+            </a:pPr>
+            <a:r>
+              <a:t/>
+            </a:r>
+            <a:endParaRPr/>
+          </a:p>
+        </p:txBody>
+      </p:sp>
+      <p:sp>
+        <p:nvSpPr>
+          <p:cNvPr id="184" name="Google Shape;184;p27"/>
+          <p:cNvSpPr txBox="1"/>
+          <p:nvPr/>
+        </p:nvSpPr>
+        <p:spPr>
+          <a:xfrm>
+            <a:off x="365400" y="4774300"/>
+            <a:ext cx="8454600" cy="360000"/>
+          </a:xfrm>
+          <a:prstGeom prst="rect">
+            <a:avLst/>
+          </a:prstGeom>
+          <a:noFill/>
+          <a:ln>
+            <a:noFill/>
+          </a:ln>
+        </p:spPr>
+        <p:txBody>
+          <a:bodyPr anchorCtr="0" anchor="t" bIns="91425" lIns="91425" spcFirstLastPara="1" rIns="91425" wrap="square" tIns="91425">
+            <a:noAutofit/>
+          </a:bodyPr>
+          <a:lstStyle/>
+          <a:p>
+            <a:pPr indent="0" lvl="0" marL="0" rtl="0" algn="l">
+              <a:spcBef>
+                <a:spcPts val="0"/>
+              </a:spcBef>
+              <a:spcAft>
+                <a:spcPts val="0"/>
+              </a:spcAft>
+              <a:buNone/>
+            </a:pPr>
+            <a:r>
+              <a:rPr lang="fr" sz="1000">
+                <a:solidFill>
+                  <a:schemeClr val="lt1"/>
+                </a:solidFill>
+                <a:latin typeface="Calibri"/>
+                <a:ea typeface="Calibri"/>
+                <a:cs typeface="Calibri"/>
+                <a:sym typeface="Calibri"/>
+              </a:rPr>
+              <a:t>Jedha - Certification AIA - Bloc 3 - Guillaume VIEL - 16 juillet 2026</a:t>
+            </a:r>
+            <a:endParaRPr sz="1000">
+              <a:solidFill>
+                <a:schemeClr val="lt1"/>
+              </a:solidFill>
+              <a:latin typeface="Calibri"/>
+              <a:ea typeface="Calibri"/>
+              <a:cs typeface="Calibri"/>
+              <a:sym typeface="Calibri"/>
+            </a:endParaRPr>
+          </a:p>
+        </p:txBody>
+      </p:sp>
+    </p:spTree>
+  </p:cSld>
+  <p:clrMapOvr>
+    <a:masterClrMapping/>
+  </p:clrMapOvr>
+</p:sld>
+</file>
+
+<file path=ppt/slides/slide16.xml><?xml version="1.0" encoding="utf-8"?>
+<p:sld xmlns:a="http://schemas.openxmlformats.org/drawingml/2006/main" xmlns:r="http://schemas.openxmlformats.org/officeDocument/2006/relationships" xmlns:mc="http://schemas.openxmlformats.org/markup-compatibility/2006" xmlns:mv="urn:schemas-microsoft-com:mac:vml" xmlns:p="http://schemas.openxmlformats.org/presentationml/2006/main" xmlns:c="http://schemas.openxmlformats.org/drawingml/2006/chart" xmlns:dgm="http://schemas.openxmlformats.org/drawingml/2006/diagram" xmlns:o="urn:schemas-microsoft-com:office:office" xmlns:v="urn:schemas-microsoft-com:vml" xmlns:pvml="urn:schemas-microsoft-com:office:powerpoint" xmlns:com="http://schemas.openxmlformats.org/drawingml/2006/compatibility" xmlns:p14="http://schemas.microsoft.com/office/powerpoint/2010/main" xmlns:p15="http://schemas.microsoft.com/office/powerpoint/2012/main" xmlns:ahyp="http://schemas.microsoft.com/office/drawing/2018/hyperlinkcolor">
+  <p:cSld>
+    <p:bg>
+      <p:bgPr>
+        <a:solidFill>
+          <a:srgbClr val="741B47"/>
+        </a:solidFill>
+      </p:bgPr>
+    </p:bg>
+    <p:spTree>
+      <p:nvGrpSpPr>
+        <p:cNvPr id="188" name="Shape 188"/>
+        <p:cNvGrpSpPr/>
+        <p:nvPr/>
+      </p:nvGrpSpPr>
+      <p:grpSpPr>
+        <a:xfrm>
+          <a:off x="0" y="0"/>
+          <a:ext cx="0" cy="0"/>
+          <a:chOff x="0" y="0"/>
+          <a:chExt cx="0" cy="0"/>
+        </a:xfrm>
+      </p:grpSpPr>
+      <p:sp>
+        <p:nvSpPr>
+          <p:cNvPr id="189" name="Google Shape;189;p28"/>
           <p:cNvSpPr txBox="1"/>
           <p:nvPr/>
         </p:nvSpPr>
@@ -9117,7 +10878,7 @@
       </p:sp>
       <p:sp>
         <p:nvSpPr>
-          <p:cNvPr id="163" name="Google Shape;163;p25"/>
+          <p:cNvPr id="190" name="Google Shape;190;p28"/>
           <p:cNvSpPr txBox="1"/>
           <p:nvPr/>
         </p:nvSpPr>
@@ -9175,7 +10936,7 @@
       </p:sp>
       <p:pic>
         <p:nvPicPr>
-          <p:cNvPr id="164" name="Google Shape;164;p25"/>
+          <p:cNvPr id="191" name="Google Shape;191;p28"/>
           <p:cNvPicPr preferRelativeResize="0"/>
           <p:nvPr/>
         </p:nvPicPr>
@@ -9202,7 +10963,7 @@
       </p:pic>
       <p:cxnSp>
         <p:nvCxnSpPr>
-          <p:cNvPr id="165" name="Google Shape;165;p25"/>
+          <p:cNvPr id="192" name="Google Shape;192;p28"/>
           <p:cNvCxnSpPr/>
           <p:nvPr/>
         </p:nvCxnSpPr>
@@ -9228,7 +10989,7 @@
       </p:cxnSp>
       <p:sp>
         <p:nvSpPr>
-          <p:cNvPr id="166" name="Google Shape;166;p25"/>
+          <p:cNvPr id="193" name="Google Shape;193;p28"/>
           <p:cNvSpPr txBox="1"/>
           <p:nvPr/>
         </p:nvSpPr>
@@ -9286,7 +11047,7 @@
       </p:sp>
       <p:sp>
         <p:nvSpPr>
-          <p:cNvPr id="167" name="Google Shape;167;p25"/>
+          <p:cNvPr id="194" name="Google Shape;194;p28"/>
           <p:cNvSpPr txBox="1"/>
           <p:nvPr/>
         </p:nvSpPr>
@@ -11687,7 +13448,7 @@
             <a:tbl>
               <a:tblPr>
                 <a:noFill/>
-                <a:tableStyleId>{B13ECEEF-8CDF-4DC7-B2DE-5FE67ECA9D0A}</a:tableStyleId>
+                <a:tableStyleId>{AE94E342-CAAB-478D-BB96-D7EA19FF5541}</a:tableStyleId>
               </a:tblPr>
               <a:tblGrid>
                 <a:gridCol w="2170625"/>

</xml_diff>

<commit_message>
docs: corrige des coquilles sur les slides finales de la présentation
</commit_message>
<xml_diff>
--- a/docs/AIA_bloc3_fraud_detection_GV.pptx
+++ b/docs/AIA_bloc3_fraud_detection_GV.pptx
@@ -10315,7 +10315,7 @@
                 <a:cs typeface="Calibri"/>
                 <a:sym typeface="Calibri"/>
               </a:rPr>
-              <a:t>contraintes des free plan…</a:t>
+              <a:t>contraintes des free plans…</a:t>
             </a:r>
             <a:endParaRPr b="1" sz="1900">
               <a:solidFill>
@@ -10352,7 +10352,7 @@
                 <a:cs typeface="Calibri"/>
                 <a:sym typeface="Calibri"/>
               </a:rPr>
-              <a:t>déploiement stack Airflow en local (complexe voire impossible sur HF ou Render)</a:t>
+              <a:t>déploiement stack Airflow en local (car complexe voire impossible sur HF ou Render)</a:t>
             </a:r>
             <a:endParaRPr b="1" sz="1900">
               <a:solidFill>
@@ -10389,7 +10389,7 @@
                 <a:cs typeface="Calibri"/>
                 <a:sym typeface="Calibri"/>
               </a:rPr>
-              <a:t>nombreux modules et nombreuses vars de config</a:t>
+              <a:t>nombreux modules et nombreuses vars de config à gérer</a:t>
             </a:r>
             <a:br>
               <a:rPr b="1" lang="fr" sz="1900">
@@ -12910,7 +12910,7 @@
                 <a:cs typeface="Calibri"/>
                 <a:sym typeface="Calibri"/>
               </a:rPr>
-              <a:t>même si leurs valeurs peuvent être bonnes, les nombreux vrais négatifs dilue le reste</a:t>
+              <a:t>même si leurs valeurs peuvent être bonnes, les nombreux vrais négatifs diluent le reste</a:t>
             </a:r>
             <a:br>
               <a:rPr b="1" lang="fr" sz="1900">
@@ -12990,7 +12990,7 @@
                 <a:cs typeface="Calibri"/>
                 <a:sym typeface="Calibri"/>
               </a:rPr>
-              <a:t>Utilisation du PR-AUC pour départager les modèles dans un premier temps (pas de dilution avec les négatifs)</a:t>
+              <a:t>Utilisation du PR-AUC pour départager les modèles dans un premier temps (pas de dilution avec les vrais négatifs TN)</a:t>
             </a:r>
             <a:endParaRPr b="1" sz="1900">
               <a:solidFill>
@@ -13448,7 +13448,7 @@
             <a:tbl>
               <a:tblPr>
                 <a:noFill/>
-                <a:tableStyleId>{AE94E342-CAAB-478D-BB96-D7EA19FF5541}</a:tableStyleId>
+                <a:tableStyleId>{2A07319E-38BD-42A5-80EC-4076616495B6}</a:tableStyleId>
               </a:tblPr>
               <a:tblGrid>
                 <a:gridCol w="2170625"/>
@@ -14916,6 +14916,285 @@
 </file>
 
 <file path=ppt/theme/theme1.xml><?xml version="1.0" encoding="utf-8"?>
+<a:theme xmlns:a="http://schemas.openxmlformats.org/drawingml/2006/main" xmlns:r="http://schemas.openxmlformats.org/officeDocument/2006/relationships">
+  <a:themeElements>
+    <a:clrScheme name="Default">
+      <a:dk1>
+        <a:srgbClr val="000000"/>
+      </a:dk1>
+      <a:lt1>
+        <a:srgbClr val="FFFFFF"/>
+      </a:lt1>
+      <a:dk2>
+        <a:srgbClr val="158158"/>
+      </a:dk2>
+      <a:lt2>
+        <a:srgbClr val="F3F3F3"/>
+      </a:lt2>
+      <a:accent1>
+        <a:srgbClr val="058DC7"/>
+      </a:accent1>
+      <a:accent2>
+        <a:srgbClr val="50B432"/>
+      </a:accent2>
+      <a:accent3>
+        <a:srgbClr val="ED561B"/>
+      </a:accent3>
+      <a:accent4>
+        <a:srgbClr val="EDEF00"/>
+      </a:accent4>
+      <a:accent5>
+        <a:srgbClr val="24CBE5"/>
+      </a:accent5>
+      <a:accent6>
+        <a:srgbClr val="64E572"/>
+      </a:accent6>
+      <a:hlink>
+        <a:srgbClr val="2200CC"/>
+      </a:hlink>
+      <a:folHlink>
+        <a:srgbClr val="551A8B"/>
+      </a:folHlink>
+    </a:clrScheme>
+    <a:fontScheme name="Office">
+      <a:majorFont>
+        <a:latin typeface="Arial"/>
+        <a:ea typeface=""/>
+        <a:cs typeface=""/>
+        <a:font script="Jpan" typeface="ＭＳ Ｐゴシック"/>
+        <a:font script="Hang" typeface="맑은 고딕"/>
+        <a:font script="Hans" typeface="宋体"/>
+        <a:font script="Hant" typeface="新細明體"/>
+        <a:font script="Arab" typeface="Times New Roman"/>
+        <a:font script="Hebr" typeface="Times New Roman"/>
+        <a:font script="Thai" typeface="Angsana New"/>
+        <a:font script="Ethi" typeface="Nyala"/>
+        <a:font script="Beng" typeface="Vrinda"/>
+        <a:font script="Gujr" typeface="Shruti"/>
+        <a:font script="Khmr" typeface="MoolBoran"/>
+        <a:font script="Knda" typeface="Tunga"/>
+        <a:font script="Guru" typeface="Raavi"/>
+        <a:font script="Cans" typeface="Euphemia"/>
+        <a:font script="Cher" typeface="Plantagenet Cherokee"/>
+        <a:font script="Yiii" typeface="Microsoft Yi Baiti"/>
+        <a:font script="Tibt" typeface="Microsoft Himalaya"/>
+        <a:font script="Thaa" typeface="MV Boli"/>
+        <a:font script="Deva" typeface="Mangal"/>
+        <a:font script="Telu" typeface="Gautami"/>
+        <a:font script="Taml" typeface="Latha"/>
+        <a:font script="Syrc" typeface="Estrangelo Edessa"/>
+        <a:font script="Orya" typeface="Kalinga"/>
+        <a:font script="Mlym" typeface="Kartika"/>
+        <a:font script="Laoo" typeface="DokChampa"/>
+        <a:font script="Sinh" typeface="Iskoola Pota"/>
+        <a:font script="Mong" typeface="Mongolian Baiti"/>
+        <a:font script="Viet" typeface="Times New Roman"/>
+        <a:font script="Uigh" typeface="Microsoft Uighur"/>
+        <a:font script="Geor" typeface="Sylfaen"/>
+      </a:majorFont>
+      <a:minorFont>
+        <a:latin typeface="Arial"/>
+        <a:ea typeface=""/>
+        <a:cs typeface=""/>
+        <a:font script="Jpan" typeface="ＭＳ Ｐゴシック"/>
+        <a:font script="Hang" typeface="맑은 고딕"/>
+        <a:font script="Hans" typeface="宋体"/>
+        <a:font script="Hant" typeface="新細明體"/>
+        <a:font script="Arab" typeface="Arial"/>
+        <a:font script="Hebr" typeface="Arial"/>
+        <a:font script="Thai" typeface="Cordia New"/>
+        <a:font script="Ethi" typeface="Nyala"/>
+        <a:font script="Beng" typeface="Vrinda"/>
+        <a:font script="Gujr" typeface="Shruti"/>
+        <a:font script="Khmr" typeface="DaunPenh"/>
+        <a:font script="Knda" typeface="Tunga"/>
+        <a:font script="Guru" typeface="Raavi"/>
+        <a:font script="Cans" typeface="Euphemia"/>
+        <a:font script="Cher" typeface="Plantagenet Cherokee"/>
+        <a:font script="Yiii" typeface="Microsoft Yi Baiti"/>
+        <a:font script="Tibt" typeface="Microsoft Himalaya"/>
+        <a:font script="Thaa" typeface="MV Boli"/>
+        <a:font script="Deva" typeface="Mangal"/>
+        <a:font script="Telu" typeface="Gautami"/>
+        <a:font script="Taml" typeface="Latha"/>
+        <a:font script="Syrc" typeface="Estrangelo Edessa"/>
+        <a:font script="Orya" typeface="Kalinga"/>
+        <a:font script="Mlym" typeface="Kartika"/>
+        <a:font script="Laoo" typeface="DokChampa"/>
+        <a:font script="Sinh" typeface="Iskoola Pota"/>
+        <a:font script="Mong" typeface="Mongolian Baiti"/>
+        <a:font script="Viet" typeface="Arial"/>
+        <a:font script="Uigh" typeface="Microsoft Uighur"/>
+        <a:font script="Geor" typeface="Sylfaen"/>
+      </a:minorFont>
+    </a:fontScheme>
+    <a:fmtScheme name="Office">
+      <a:fillStyleLst>
+        <a:solidFill>
+          <a:schemeClr val="phClr"/>
+        </a:solidFill>
+        <a:gradFill rotWithShape="1">
+          <a:gsLst>
+            <a:gs pos="0">
+              <a:schemeClr val="phClr">
+                <a:tint val="50000"/>
+                <a:satMod val="300000"/>
+              </a:schemeClr>
+            </a:gs>
+            <a:gs pos="35000">
+              <a:schemeClr val="phClr">
+                <a:tint val="37000"/>
+                <a:satMod val="300000"/>
+              </a:schemeClr>
+            </a:gs>
+            <a:gs pos="100000">
+              <a:schemeClr val="phClr">
+                <a:tint val="15000"/>
+                <a:satMod val="350000"/>
+              </a:schemeClr>
+            </a:gs>
+          </a:gsLst>
+          <a:lin ang="16200000" scaled="1"/>
+        </a:gradFill>
+        <a:gradFill rotWithShape="1">
+          <a:gsLst>
+            <a:gs pos="0">
+              <a:schemeClr val="phClr">
+                <a:tint val="100000"/>
+                <a:shade val="100000"/>
+                <a:satMod val="130000"/>
+              </a:schemeClr>
+            </a:gs>
+            <a:gs pos="100000">
+              <a:schemeClr val="phClr">
+                <a:tint val="50000"/>
+                <a:shade val="100000"/>
+                <a:satMod val="350000"/>
+              </a:schemeClr>
+            </a:gs>
+          </a:gsLst>
+          <a:lin ang="16200000" scaled="0"/>
+        </a:gradFill>
+      </a:fillStyleLst>
+      <a:lnStyleLst>
+        <a:ln w="9525" cap="flat" cmpd="sng" algn="ctr">
+          <a:solidFill>
+            <a:schemeClr val="phClr">
+              <a:shade val="95000"/>
+              <a:satMod val="105000"/>
+            </a:schemeClr>
+          </a:solidFill>
+          <a:prstDash val="solid"/>
+        </a:ln>
+        <a:ln w="25400" cap="flat" cmpd="sng" algn="ctr">
+          <a:solidFill>
+            <a:schemeClr val="phClr"/>
+          </a:solidFill>
+          <a:prstDash val="solid"/>
+        </a:ln>
+        <a:ln w="38100" cap="flat" cmpd="sng" algn="ctr">
+          <a:solidFill>
+            <a:schemeClr val="phClr"/>
+          </a:solidFill>
+          <a:prstDash val="solid"/>
+        </a:ln>
+      </a:lnStyleLst>
+      <a:effectStyleLst>
+        <a:effectStyle>
+          <a:effectLst>
+            <a:outerShdw blurRad="40000" dist="20000" dir="5400000" rotWithShape="0">
+              <a:srgbClr val="000000">
+                <a:alpha val="38000"/>
+              </a:srgbClr>
+            </a:outerShdw>
+          </a:effectLst>
+        </a:effectStyle>
+        <a:effectStyle>
+          <a:effectLst>
+            <a:outerShdw blurRad="40000" dist="23000" dir="5400000" rotWithShape="0">
+              <a:srgbClr val="000000">
+                <a:alpha val="35000"/>
+              </a:srgbClr>
+            </a:outerShdw>
+          </a:effectLst>
+        </a:effectStyle>
+        <a:effectStyle>
+          <a:effectLst>
+            <a:outerShdw blurRad="40000" dist="23000" dir="5400000" rotWithShape="0">
+              <a:srgbClr val="000000">
+                <a:alpha val="35000"/>
+              </a:srgbClr>
+            </a:outerShdw>
+          </a:effectLst>
+          <a:scene3d>
+            <a:camera prst="orthographicFront">
+              <a:rot lat="0" lon="0" rev="0"/>
+            </a:camera>
+            <a:lightRig rig="threePt" dir="t">
+              <a:rot lat="0" lon="0" rev="1200000"/>
+            </a:lightRig>
+          </a:scene3d>
+          <a:sp3d>
+            <a:bevelT w="63500" h="25400"/>
+          </a:sp3d>
+        </a:effectStyle>
+      </a:effectStyleLst>
+      <a:bgFillStyleLst>
+        <a:solidFill>
+          <a:schemeClr val="phClr"/>
+        </a:solidFill>
+        <a:gradFill rotWithShape="1">
+          <a:gsLst>
+            <a:gs pos="0">
+              <a:schemeClr val="phClr">
+                <a:tint val="40000"/>
+                <a:satMod val="350000"/>
+              </a:schemeClr>
+            </a:gs>
+            <a:gs pos="40000">
+              <a:schemeClr val="phClr">
+                <a:tint val="45000"/>
+                <a:shade val="99000"/>
+                <a:satMod val="350000"/>
+              </a:schemeClr>
+            </a:gs>
+            <a:gs pos="100000">
+              <a:schemeClr val="phClr">
+                <a:shade val="20000"/>
+                <a:satMod val="255000"/>
+              </a:schemeClr>
+            </a:gs>
+          </a:gsLst>
+          <a:path path="circle">
+            <a:fillToRect l="50000" t="-80000" r="50000" b="180000"/>
+          </a:path>
+        </a:gradFill>
+        <a:gradFill rotWithShape="1">
+          <a:gsLst>
+            <a:gs pos="0">
+              <a:schemeClr val="phClr">
+                <a:tint val="80000"/>
+                <a:satMod val="300000"/>
+              </a:schemeClr>
+            </a:gs>
+            <a:gs pos="100000">
+              <a:schemeClr val="phClr">
+                <a:shade val="30000"/>
+                <a:satMod val="200000"/>
+              </a:schemeClr>
+            </a:gs>
+          </a:gsLst>
+          <a:path path="circle">
+            <a:fillToRect l="50000" t="50000" r="50000" b="50000"/>
+          </a:path>
+        </a:gradFill>
+      </a:bgFillStyleLst>
+    </a:fmtScheme>
+  </a:themeElements>
+</a:theme>
+</file>
+
+<file path=ppt/theme/theme2.xml><?xml version="1.0" encoding="utf-8"?>
 <a:theme xmlns:a="http://schemas.openxmlformats.org/drawingml/2006/main" xmlns:r="http://schemas.openxmlformats.org/officeDocument/2006/relationships" name="Simple Light">
   <a:themeElements>
     <a:clrScheme name="Simple Light">
@@ -15192,283 +15471,4 @@
     </a:fmtScheme>
   </a:themeElements>
 </a:theme>
-</file>
-
-<file path=ppt/theme/theme2.xml><?xml version="1.0" encoding="utf-8"?>
-<a:theme xmlns:a="http://schemas.openxmlformats.org/drawingml/2006/main" xmlns:r="http://schemas.openxmlformats.org/officeDocument/2006/relationships">
-  <a:themeElements>
-    <a:clrScheme name="Default">
-      <a:dk1>
-        <a:srgbClr val="000000"/>
-      </a:dk1>
-      <a:lt1>
-        <a:srgbClr val="FFFFFF"/>
-      </a:lt1>
-      <a:dk2>
-        <a:srgbClr val="158158"/>
-      </a:dk2>
-      <a:lt2>
-        <a:srgbClr val="F3F3F3"/>
-      </a:lt2>
-      <a:accent1>
-        <a:srgbClr val="058DC7"/>
-      </a:accent1>
-      <a:accent2>
-        <a:srgbClr val="50B432"/>
-      </a:accent2>
-      <a:accent3>
-        <a:srgbClr val="ED561B"/>
-      </a:accent3>
-      <a:accent4>
-        <a:srgbClr val="EDEF00"/>
-      </a:accent4>
-      <a:accent5>
-        <a:srgbClr val="24CBE5"/>
-      </a:accent5>
-      <a:accent6>
-        <a:srgbClr val="64E572"/>
-      </a:accent6>
-      <a:hlink>
-        <a:srgbClr val="2200CC"/>
-      </a:hlink>
-      <a:folHlink>
-        <a:srgbClr val="551A8B"/>
-      </a:folHlink>
-    </a:clrScheme>
-    <a:fontScheme name="Office">
-      <a:majorFont>
-        <a:latin typeface="Arial"/>
-        <a:ea typeface=""/>
-        <a:cs typeface=""/>
-        <a:font script="Jpan" typeface="ＭＳ Ｐゴシック"/>
-        <a:font script="Hang" typeface="맑은 고딕"/>
-        <a:font script="Hans" typeface="宋体"/>
-        <a:font script="Hant" typeface="新細明體"/>
-        <a:font script="Arab" typeface="Times New Roman"/>
-        <a:font script="Hebr" typeface="Times New Roman"/>
-        <a:font script="Thai" typeface="Angsana New"/>
-        <a:font script="Ethi" typeface="Nyala"/>
-        <a:font script="Beng" typeface="Vrinda"/>
-        <a:font script="Gujr" typeface="Shruti"/>
-        <a:font script="Khmr" typeface="MoolBoran"/>
-        <a:font script="Knda" typeface="Tunga"/>
-        <a:font script="Guru" typeface="Raavi"/>
-        <a:font script="Cans" typeface="Euphemia"/>
-        <a:font script="Cher" typeface="Plantagenet Cherokee"/>
-        <a:font script="Yiii" typeface="Microsoft Yi Baiti"/>
-        <a:font script="Tibt" typeface="Microsoft Himalaya"/>
-        <a:font script="Thaa" typeface="MV Boli"/>
-        <a:font script="Deva" typeface="Mangal"/>
-        <a:font script="Telu" typeface="Gautami"/>
-        <a:font script="Taml" typeface="Latha"/>
-        <a:font script="Syrc" typeface="Estrangelo Edessa"/>
-        <a:font script="Orya" typeface="Kalinga"/>
-        <a:font script="Mlym" typeface="Kartika"/>
-        <a:font script="Laoo" typeface="DokChampa"/>
-        <a:font script="Sinh" typeface="Iskoola Pota"/>
-        <a:font script="Mong" typeface="Mongolian Baiti"/>
-        <a:font script="Viet" typeface="Times New Roman"/>
-        <a:font script="Uigh" typeface="Microsoft Uighur"/>
-        <a:font script="Geor" typeface="Sylfaen"/>
-      </a:majorFont>
-      <a:minorFont>
-        <a:latin typeface="Arial"/>
-        <a:ea typeface=""/>
-        <a:cs typeface=""/>
-        <a:font script="Jpan" typeface="ＭＳ Ｐゴシック"/>
-        <a:font script="Hang" typeface="맑은 고딕"/>
-        <a:font script="Hans" typeface="宋体"/>
-        <a:font script="Hant" typeface="新細明體"/>
-        <a:font script="Arab" typeface="Arial"/>
-        <a:font script="Hebr" typeface="Arial"/>
-        <a:font script="Thai" typeface="Cordia New"/>
-        <a:font script="Ethi" typeface="Nyala"/>
-        <a:font script="Beng" typeface="Vrinda"/>
-        <a:font script="Gujr" typeface="Shruti"/>
-        <a:font script="Khmr" typeface="DaunPenh"/>
-        <a:font script="Knda" typeface="Tunga"/>
-        <a:font script="Guru" typeface="Raavi"/>
-        <a:font script="Cans" typeface="Euphemia"/>
-        <a:font script="Cher" typeface="Plantagenet Cherokee"/>
-        <a:font script="Yiii" typeface="Microsoft Yi Baiti"/>
-        <a:font script="Tibt" typeface="Microsoft Himalaya"/>
-        <a:font script="Thaa" typeface="MV Boli"/>
-        <a:font script="Deva" typeface="Mangal"/>
-        <a:font script="Telu" typeface="Gautami"/>
-        <a:font script="Taml" typeface="Latha"/>
-        <a:font script="Syrc" typeface="Estrangelo Edessa"/>
-        <a:font script="Orya" typeface="Kalinga"/>
-        <a:font script="Mlym" typeface="Kartika"/>
-        <a:font script="Laoo" typeface="DokChampa"/>
-        <a:font script="Sinh" typeface="Iskoola Pota"/>
-        <a:font script="Mong" typeface="Mongolian Baiti"/>
-        <a:font script="Viet" typeface="Arial"/>
-        <a:font script="Uigh" typeface="Microsoft Uighur"/>
-        <a:font script="Geor" typeface="Sylfaen"/>
-      </a:minorFont>
-    </a:fontScheme>
-    <a:fmtScheme name="Office">
-      <a:fillStyleLst>
-        <a:solidFill>
-          <a:schemeClr val="phClr"/>
-        </a:solidFill>
-        <a:gradFill rotWithShape="1">
-          <a:gsLst>
-            <a:gs pos="0">
-              <a:schemeClr val="phClr">
-                <a:tint val="50000"/>
-                <a:satMod val="300000"/>
-              </a:schemeClr>
-            </a:gs>
-            <a:gs pos="35000">
-              <a:schemeClr val="phClr">
-                <a:tint val="37000"/>
-                <a:satMod val="300000"/>
-              </a:schemeClr>
-            </a:gs>
-            <a:gs pos="100000">
-              <a:schemeClr val="phClr">
-                <a:tint val="15000"/>
-                <a:satMod val="350000"/>
-              </a:schemeClr>
-            </a:gs>
-          </a:gsLst>
-          <a:lin ang="16200000" scaled="1"/>
-        </a:gradFill>
-        <a:gradFill rotWithShape="1">
-          <a:gsLst>
-            <a:gs pos="0">
-              <a:schemeClr val="phClr">
-                <a:tint val="100000"/>
-                <a:shade val="100000"/>
-                <a:satMod val="130000"/>
-              </a:schemeClr>
-            </a:gs>
-            <a:gs pos="100000">
-              <a:schemeClr val="phClr">
-                <a:tint val="50000"/>
-                <a:shade val="100000"/>
-                <a:satMod val="350000"/>
-              </a:schemeClr>
-            </a:gs>
-          </a:gsLst>
-          <a:lin ang="16200000" scaled="0"/>
-        </a:gradFill>
-      </a:fillStyleLst>
-      <a:lnStyleLst>
-        <a:ln w="9525" cap="flat" cmpd="sng" algn="ctr">
-          <a:solidFill>
-            <a:schemeClr val="phClr">
-              <a:shade val="95000"/>
-              <a:satMod val="105000"/>
-            </a:schemeClr>
-          </a:solidFill>
-          <a:prstDash val="solid"/>
-        </a:ln>
-        <a:ln w="25400" cap="flat" cmpd="sng" algn="ctr">
-          <a:solidFill>
-            <a:schemeClr val="phClr"/>
-          </a:solidFill>
-          <a:prstDash val="solid"/>
-        </a:ln>
-        <a:ln w="38100" cap="flat" cmpd="sng" algn="ctr">
-          <a:solidFill>
-            <a:schemeClr val="phClr"/>
-          </a:solidFill>
-          <a:prstDash val="solid"/>
-        </a:ln>
-      </a:lnStyleLst>
-      <a:effectStyleLst>
-        <a:effectStyle>
-          <a:effectLst>
-            <a:outerShdw blurRad="40000" dist="20000" dir="5400000" rotWithShape="0">
-              <a:srgbClr val="000000">
-                <a:alpha val="38000"/>
-              </a:srgbClr>
-            </a:outerShdw>
-          </a:effectLst>
-        </a:effectStyle>
-        <a:effectStyle>
-          <a:effectLst>
-            <a:outerShdw blurRad="40000" dist="23000" dir="5400000" rotWithShape="0">
-              <a:srgbClr val="000000">
-                <a:alpha val="35000"/>
-              </a:srgbClr>
-            </a:outerShdw>
-          </a:effectLst>
-        </a:effectStyle>
-        <a:effectStyle>
-          <a:effectLst>
-            <a:outerShdw blurRad="40000" dist="23000" dir="5400000" rotWithShape="0">
-              <a:srgbClr val="000000">
-                <a:alpha val="35000"/>
-              </a:srgbClr>
-            </a:outerShdw>
-          </a:effectLst>
-          <a:scene3d>
-            <a:camera prst="orthographicFront">
-              <a:rot lat="0" lon="0" rev="0"/>
-            </a:camera>
-            <a:lightRig rig="threePt" dir="t">
-              <a:rot lat="0" lon="0" rev="1200000"/>
-            </a:lightRig>
-          </a:scene3d>
-          <a:sp3d>
-            <a:bevelT w="63500" h="25400"/>
-          </a:sp3d>
-        </a:effectStyle>
-      </a:effectStyleLst>
-      <a:bgFillStyleLst>
-        <a:solidFill>
-          <a:schemeClr val="phClr"/>
-        </a:solidFill>
-        <a:gradFill rotWithShape="1">
-          <a:gsLst>
-            <a:gs pos="0">
-              <a:schemeClr val="phClr">
-                <a:tint val="40000"/>
-                <a:satMod val="350000"/>
-              </a:schemeClr>
-            </a:gs>
-            <a:gs pos="40000">
-              <a:schemeClr val="phClr">
-                <a:tint val="45000"/>
-                <a:shade val="99000"/>
-                <a:satMod val="350000"/>
-              </a:schemeClr>
-            </a:gs>
-            <a:gs pos="100000">
-              <a:schemeClr val="phClr">
-                <a:shade val="20000"/>
-                <a:satMod val="255000"/>
-              </a:schemeClr>
-            </a:gs>
-          </a:gsLst>
-          <a:path path="circle">
-            <a:fillToRect l="50000" t="-80000" r="50000" b="180000"/>
-          </a:path>
-        </a:gradFill>
-        <a:gradFill rotWithShape="1">
-          <a:gsLst>
-            <a:gs pos="0">
-              <a:schemeClr val="phClr">
-                <a:tint val="80000"/>
-                <a:satMod val="300000"/>
-              </a:schemeClr>
-            </a:gs>
-            <a:gs pos="100000">
-              <a:schemeClr val="phClr">
-                <a:shade val="30000"/>
-                <a:satMod val="200000"/>
-              </a:schemeClr>
-            </a:gs>
-          </a:gsLst>
-          <a:path path="circle">
-            <a:fillToRect l="50000" t="50000" r="50000" b="50000"/>
-          </a:path>
-        </a:gradFill>
-      </a:bgFillStyleLst>
-    </a:fmtScheme>
-  </a:themeElements>
-</a:theme>
 </file>
</xml_diff>